<commit_message>
docs(week5): revise form 4 presentation (9 slides)
- add "how the phone knows" slide in plain language
- state why the target changed and who is out of scope
- bring back the in-app ("내 폰 보호") adoption path
- plain-language metric labels, expected-impact line

Co-Authored-By: Claude Fable 5.1 <noreply@anthropic.com>
</commit_message>
<xml_diff>
--- a/docs/week5/form4_presentation.pptx
+++ b/docs/week5/form4_presentation.pptx
@@ -13,9 +13,10 @@
     <p:sldId id="261" r:id="rId7"/>
     <p:sldId id="262" r:id="rId8"/>
     <p:sldId id="263" r:id="rId9"/>
+    <p:sldId id="264" r:id="rId10"/>
   </p:sldIdLst>
   <p:notesMasterIdLst>
-    <p:notesMasterId r:id="rId10"/>
+    <p:notesMasterId r:id="rId11"/>
   </p:notesMasterIdLst>
   <p:sldSz cx="9144000" cy="5143500"/>
   <p:notesSz cx="5143500" cy="9144000"/>
@@ -509,7 +510,7 @@
           <a:p>
             <a:r>
               <a:rPr lang="en-US" dirty="0"/>
-              <a:t>안녕하세요, 김성민입니다. 이번 주 문제정의서의 컨셉은 「멈칫」, 본인이 켜는 도박 브레이크입니다. 지난주 피드백을 받고 누구의 문제인지를 다시 정했고, 그 결과를 5분 동안 말씀드리겠습니다.</a:t>
+              <a:t>안녕하세요, 김성민입니다. 이번 주 문제정의서의 컨셉은 「멈칫」, 본인이 켜는 도박 브레이크입니다. 지난주 피드백을 받고 누구의 문제인지를 다시 정했고, 그 결과를 6분 안에 말씀드리겠습니다.</a:t>
             </a:r>
             <a:endParaRPr lang="en-US" dirty="0"/>
           </a:p>
@@ -597,7 +598,7 @@
           <a:p>
             <a:r>
               <a:rPr lang="en-US" dirty="0"/>
-              <a:t>4주차까지는 보호자를 1차 고객으로 두었습니다. 그런데 근거를 다시 보니, 실태조사·자진신고·상담 통계가 모두 '이미 돈을 잃어본 청소년'에 대한 것이었습니다. 최근 6개월 도박을 이어 간 청소년이 약 3만 2천 명인데 상담까지 온 건 5,838명이고, 자진신고한 학생은 평균 10개월 동안 300만 원을 잃은 뒤에야 왔습니다. 그래서 1차 사용자를 '돈을 잃어봤고 끊고 싶은 청소년 본인'으로 올리고, 보호자는 본인이 고르는 신뢰인으로 바꿨습니다. 감시하지 않는다, 돈이 나가기 전에 멈춘다는 핵심은 그대로입니다.</a:t>
+              <a:t>4주차까지는 보호자를 1차 고객으로 두었습니다. 그런데 근거를 다시 보니, 실태조사·자진신고·상담 통계가 모두 '이미 돈을 잃어본 청소년'에 대한 것이었습니다. 최근 6개월 도박을 이어 간 청소년이 약 3만 2천 명인데 상담까지 온 건 5,838명이고, 자진신고한 학생은 평균 10개월 동안 300만 원을 잃은 뒤에야 왔습니다. 그래서 1차 사용자를 '돈을 잃어봤고 끊고 싶은 청소년 본인'으로 올리고, 보호자는 본인이 고르는 신뢰인으로 바꿨습니다. 끊을 생각이 전혀 없는 아이는 대상이 아니고, 끊고 싶은데 못 끊는 아이가 타깃입니다. 감시하지 않는다, 돈이 나가기 전에 멈춘다는 핵심은 그대로입니다.</a:t>
             </a:r>
             <a:endParaRPr lang="en-US" dirty="0"/>
           </a:p>
@@ -773,7 +774,7 @@
           <a:p>
             <a:r>
               <a:rPr lang="en-US" dirty="0"/>
-              <a:t>기존 수단을 보면, 해외 자기차단 앱과 국내 자녀안심 앱은 모두 주소 목록에 의존해서 새 주소 한 번에 뚫립니다. 보호자 통제형은 아이에게 감시로 읽혀 지워지고, 자진신고와 1336은 본인이 찾아가야 작동합니다. 그래서 주소와 무관하게, 재접속과 충전 순간에, 본인이 켜는 개입은 비어 있습니다. 저는 이 자리를 화면 내용, 즉 OCR 텍스트와 이미지를 함께 보는 온디바이스 모델로 채우려고 합니다.</a:t>
+              <a:t>기존 수단을 보면, 해외 자기차단 앱과 국내 자녀안심 앱은 모두 주소 목록에 의존해서 새 주소 한 번에 뚫립니다. 보호자 통제형은 아이에게 감시로 읽혀 지워지고, 자진신고와 1336은 본인이 찾아가야 작동합니다. 그래서 주소와 무관하게, 재접속과 충전 순간에, 본인이 켜는 개입은 비어 있습니다. 저는 이 자리를 주소가 아니라 화면을 읽어 판정하는 방식으로 채우려고 합니다. 방법은 7장에서 말씀드립니다. 그리고 따로 앱을 깔게 하는 게 아니라, 이미 쓰고 있는 보안 앱의 '내 폰 보호' 기능 안에 넣어서 설치 장벽부터 없앱니다.</a:t>
             </a:r>
             <a:endParaRPr lang="en-US" dirty="0"/>
           </a:p>
@@ -1037,7 +1038,7 @@
           <a:p>
             <a:r>
               <a:rPr lang="en-US" dirty="0"/>
-              <a:t>성공 기준은 기술 지표와 행동 지표로 나눴습니다. 융합 모델 F1 0.90, 정상 게임과 결제 화면 오탐률 2% 이하, 충전 직전 화면 재현율 0.90이 기술 쪽이고, 핵심 행동 지표는 쿨다운에서 '나가기'를 고르는 비율 70%입니다. 데이터는 오늘 기준 도박 화면 76장, 정상 화면 70장을 모았고 7주차까지 1,000장으로 늘립니다. 충전 화면은 로그인 뒤에 있어 확보가 어렵다는 위험도 계획서에 적었습니다. 7주차 인터뷰, 8주차 종이 프로토타입으로 30초가 적당한지 확인하고, 11주차 중간발표에서 안드로이드 데모를 보여드리겠습니다.</a:t>
+              <a:t>'폰이 그게 도박 화면인지 어떻게 아느냐'는 질문에 답하는 장입니다. 불법 사이트는 간판, 즉 주소를 매일 바꾸지만 가게 안, 즉 화면은 그대로입니다. 그래서 주소 목록이 아니라 화면을 봅니다. 화면을 폰 안에서 캡처해서, 글자를 읽는 눈과 생김새를 보는 눈을 합쳐 도박 화면인지 충전 화면인지 판정하고, 결과에 따라 약속 카드나 쿨다운을 띄웁니다. 가르칠 데이터는 2,000~3,000장이고, 정상 게임을 도박으로 잘못 잡지 않도록 헷갈리는 정상 화면을 일부러 많이 넣습니다. 판정은 폰 안에서 1초 안에 끝나고, 화면은 밖으로 나가지 않습니다. 세부 기술 구성은 계획서에 있습니다.</a:t>
             </a:r>
             <a:endParaRPr lang="en-US" dirty="0"/>
           </a:p>
@@ -1125,7 +1126,7 @@
           <a:p>
             <a:r>
               <a:rPr lang="en-US" dirty="0"/>
-              <a:t>정리하면, 목표는 차단이 아니라 다시 들어가도 충전 전에 스스로 나오게 하는 것입니다. 감시하지 않고, 주소와 무관하며, 본인이 켜고 정합니다. 질문과 피드백 부탁드립니다.</a:t>
+              <a:t>성공 기준은 기술 지표와 행동 지표로 나눴습니다. 융합 모델 F1 0.90, 정상 게임과 결제 화면 오탐률 2% 이하, 충전 직전 화면 재현율 0.90이 기술 쪽이고, 핵심 행동 지표는 쿨다운에서 '나가기'를 고르는 비율 70%입니다. 데이터는 오늘 기준 도박 화면 76장, 정상 화면 70장을 모았고 7주차까지 1,000장으로 늘립니다. 충전 화면은 로그인 뒤에 있어 확보가 어렵다는 위험도 계획서에 적었습니다. 7주차 인터뷰, 8주차 종이 프로토타입으로 30초가 적당한지 확인하고, 11주차 중간발표에서 안드로이드 데모를 보여드리겠습니다.</a:t>
             </a:r>
             <a:endParaRPr lang="en-US" dirty="0"/>
           </a:p>
@@ -1149,6 +1150,94 @@
             <a:fld id="{F7021451-1387-4CA6-816F-3879F97B5CBC}" type="slidenum">
               <a:rPr lang="en-US"/>
               <a:t>8</a:t>
+            </a:fld>
+            <a:endParaRPr lang="en-US"/>
+          </a:p>
+        </p:txBody>
+      </p:sp>
+    </p:spTree>
+    <p:extLst>
+      <p:ext uri="{BB962C8B-B14F-4D97-AF65-F5344CB8AC3E}">
+        <p14:creationId xmlns:p14="http://schemas.microsoft.com/office/powerpoint/2010/main" val="1024086991"/>
+      </p:ext>
+    </p:extLst>
+  </p:cSld>
+  <p:clrMapOvr>
+    <a:masterClrMapping/>
+  </p:clrMapOvr>
+</p:notes>
+</file>
+
+<file path=ppt/notesSlides/notesSlide9.xml><?xml version="1.0" encoding="utf-8"?>
+<p:notes xmlns:a="http://schemas.openxmlformats.org/drawingml/2006/main" xmlns:r="http://schemas.openxmlformats.org/officeDocument/2006/relationships" xmlns:p="http://schemas.openxmlformats.org/presentationml/2006/main">
+  <p:cSld>
+    <p:spTree>
+      <p:nvGrpSpPr>
+        <p:cNvPr id="1" name=""/>
+        <p:cNvGrpSpPr/>
+        <p:nvPr/>
+      </p:nvGrpSpPr>
+      <p:grpSpPr>
+        <a:xfrm>
+          <a:off x="0" y="0"/>
+          <a:ext cx="0" cy="0"/>
+          <a:chOff x="0" y="0"/>
+          <a:chExt cx="0" cy="0"/>
+        </a:xfrm>
+      </p:grpSpPr>
+      <p:sp>
+        <p:nvSpPr>
+          <p:cNvPr id="2" name="Slide Image Placeholder 1"/>
+          <p:cNvSpPr>
+            <a:spLocks noGrp="1" noRot="1" noChangeAspect="1"/>
+          </p:cNvSpPr>
+          <p:nvPr>
+            <p:ph type="sldImg"/>
+          </p:nvPr>
+        </p:nvSpPr>
+        <p:spPr/>
+      </p:sp>
+      <p:sp>
+        <p:nvSpPr>
+          <p:cNvPr id="3" name="Notes Placeholder 2"/>
+          <p:cNvSpPr>
+            <a:spLocks noGrp="1"/>
+          </p:cNvSpPr>
+          <p:nvPr>
+            <p:ph type="body" idx="1"/>
+          </p:nvPr>
+        </p:nvSpPr>
+        <p:spPr/>
+        <p:txBody>
+          <a:bodyPr/>
+          <a:lstStyle/>
+          <a:p>
+            <a:r>
+              <a:rPr lang="en-US" dirty="0"/>
+              <a:t>정리하면, 목표는 차단이 아니라 다시 들어가도 충전 전에 스스로 나오게 하는 것입니다. 감시하지 않고, 주소와 무관하며, 본인이 켜고 정합니다. 상담 밖에 있는 3만 2천 명에게 상담보다 먼저 닿는 것이 기대 효과입니다. 질문과 피드백 부탁드립니다.</a:t>
+            </a:r>
+            <a:endParaRPr lang="en-US" dirty="0"/>
+          </a:p>
+        </p:txBody>
+      </p:sp>
+      <p:sp>
+        <p:nvSpPr>
+          <p:cNvPr id="4" name="Slide Number Placeholder 3"/>
+          <p:cNvSpPr>
+            <a:spLocks noGrp="1"/>
+          </p:cNvSpPr>
+          <p:nvPr>
+            <p:ph type="sldNum" sz="quarter" idx="10"/>
+          </p:nvPr>
+        </p:nvSpPr>
+        <p:spPr/>
+        <p:txBody>
+          <a:bodyPr/>
+          <a:lstStyle/>
+          <a:p>
+            <a:fld id="{F7021451-1387-4CA6-816F-3879F97B5CBC}" type="slidenum">
+              <a:rPr lang="en-US"/>
+              <a:t>9</a:t>
             </a:fld>
             <a:endParaRPr lang="en-US"/>
           </a:p>
@@ -2030,11 +2119,11 @@
         <p:spPr>
           <a:xfrm>
             <a:off x="457200" y="1051560"/>
-            <a:ext cx="3840480" cy="1325880"/>
+            <a:ext cx="3840480" cy="1143000"/>
           </a:xfrm>
           <a:prstGeom prst="roundRect">
             <a:avLst>
-              <a:gd name="adj" fmla="val 5517"/>
+              <a:gd name="adj" fmla="val 6400"/>
             </a:avLst>
           </a:prstGeom>
           <a:solidFill>
@@ -2090,8 +2179,8 @@
         </p:nvSpPr>
         <p:spPr>
           <a:xfrm>
-            <a:off x="685800" y="1481328"/>
-            <a:ext cx="3474720" cy="731520"/>
+            <a:off x="685800" y="1463040"/>
+            <a:ext cx="3474720" cy="685800"/>
           </a:xfrm>
           <a:prstGeom prst="rect">
             <a:avLst/>
@@ -2138,30 +2227,45 @@
           </a:p>
         </p:txBody>
       </p:sp>
-      <p:pic>
-        <p:nvPicPr>
-          <p:cNvPr id="6" name="arrow" descr="preencoded.png">    </p:cNvPr>
-          <p:cNvPicPr>
-            <a:picLocks noChangeAspect="1"/>
-          </p:cNvPicPr>
-          <p:nvPr/>
-        </p:nvPicPr>
-        <p:blipFill>
-          <a:blip r:embed="rId1"/>
-          <a:stretch>
-            <a:fillRect/>
-          </a:stretch>
-        </p:blipFill>
-        <p:spPr>
-          <a:xfrm>
-            <a:off x="2240280" y="2450592"/>
-            <a:ext cx="274320" cy="274320"/>
-          </a:xfrm>
-          <a:prstGeom prst="rect">
-            <a:avLst/>
-          </a:prstGeom>
-        </p:spPr>
-      </p:pic>
+      <p:sp>
+        <p:nvSpPr>
+          <p:cNvPr id="6" name="bridge"/>
+          <p:cNvSpPr txBox="1"/>
+          <p:nvPr/>
+        </p:nvSpPr>
+        <p:spPr>
+          <a:xfrm>
+            <a:off x="457200" y="2267712"/>
+            <a:ext cx="3840480" cy="457200"/>
+          </a:xfrm>
+          <a:prstGeom prst="rect">
+            <a:avLst/>
+          </a:prstGeom>
+          <a:noFill/>
+          <a:ln/>
+        </p:spPr>
+        <p:txBody>
+          <a:bodyPr wrap="square" lIns="0" tIns="0" rIns="0" bIns="0" rtlCol="0" anchor="ctr"/>
+          <a:lstStyle/>
+          <a:p>
+            <a:pPr indent="0" marL="0">
+              <a:buNone/>
+            </a:pPr>
+            <a:r>
+              <a:rPr lang="en-US" sz="1150" b="1" dirty="0">
+                <a:solidFill>
+                  <a:schemeClr val="tx1"/>
+                </a:solidFill>
+                <a:latin typeface="Malgun Gothic" pitchFamily="34" charset="0"/>
+                <a:ea typeface="Malgun Gothic" pitchFamily="34" charset="-122"/>
+                <a:cs typeface="Malgun Gothic" pitchFamily="34" charset="-120"/>
+              </a:rPr>
+              <a:t>↓  세 숫자 모두 '이미 돈을 잃은' 청소년의 것 → 니즈는 본인에게 있다</a:t>
+            </a:r>
+            <a:endParaRPr lang="en-US" sz="1150" dirty="0"/>
+          </a:p>
+        </p:txBody>
+      </p:sp>
       <p:sp>
         <p:nvSpPr>
           <p:cNvPr id="7" name="after card"/>
@@ -2171,11 +2275,11 @@
         <p:spPr>
           <a:xfrm>
             <a:off x="457200" y="2788920"/>
-            <a:ext cx="3840480" cy="1783080"/>
+            <a:ext cx="3840480" cy="1828800"/>
           </a:xfrm>
           <a:prstGeom prst="roundRect">
             <a:avLst>
-              <a:gd name="adj" fmla="val 4103"/>
+              <a:gd name="adj" fmla="val 4000"/>
             </a:avLst>
           </a:prstGeom>
           <a:solidFill>
@@ -2186,7 +2290,7 @@
       </p:sp>
       <p:sp>
         <p:nvSpPr>
-          <p:cNvPr id="8" name="Text 5"/>
+          <p:cNvPr id="8" name="Text 6"/>
           <p:cNvSpPr txBox="1"/>
           <p:nvPr/>
         </p:nvSpPr>
@@ -2225,14 +2329,14 @@
       </p:sp>
       <p:sp>
         <p:nvSpPr>
-          <p:cNvPr id="9" name="Text 6"/>
+          <p:cNvPr id="9" name="Text 7"/>
           <p:cNvSpPr txBox="1"/>
           <p:nvPr/>
         </p:nvSpPr>
         <p:spPr>
           <a:xfrm>
             <a:off x="685800" y="3218688"/>
-            <a:ext cx="3429000" cy="1234440"/>
+            <a:ext cx="3429000" cy="1325880"/>
           </a:xfrm>
           <a:prstGeom prst="rect">
             <a:avLst/>
@@ -2334,6 +2438,26 @@
             </a:r>
             <a:endParaRPr lang="en-US" sz="1400" dirty="0"/>
           </a:p>
+          <a:p>
+            <a:pPr indent="0" marL="0">
+              <a:spcAft>
+                <a:spcPts val="600"/>
+              </a:spcAft>
+              <a:buNone/>
+            </a:pPr>
+            <a:r>
+              <a:rPr lang="en-US" sz="1200" dirty="0">
+                <a:solidFill>
+                  <a:schemeClr val="tx2"/>
+                </a:solidFill>
+                <a:latin typeface="Malgun Gothic" pitchFamily="34" charset="0"/>
+                <a:ea typeface="Malgun Gothic" pitchFamily="34" charset="-122"/>
+                <a:cs typeface="Malgun Gothic" pitchFamily="34" charset="-120"/>
+              </a:rPr>
+              <a:t>끊을 생각이 없는 아이는 대상이 아니다 — 끊고 싶은데 못 끊는 아이가 타깃</a:t>
+            </a:r>
+            <a:endParaRPr lang="en-US" sz="1400" dirty="0"/>
+          </a:p>
         </p:txBody>
       </p:sp>
       <p:sp>
@@ -2377,7 +2501,7 @@
       </p:sp>
       <p:sp>
         <p:nvSpPr>
-          <p:cNvPr id="11" name="Text 8"/>
+          <p:cNvPr id="11" name="Text 9"/>
           <p:cNvSpPr txBox="1"/>
           <p:nvPr/>
         </p:nvSpPr>
@@ -2416,7 +2540,7 @@
       </p:sp>
       <p:sp>
         <p:nvSpPr>
-          <p:cNvPr id="12" name="Text 9"/>
+          <p:cNvPr id="12" name="Text 10"/>
           <p:cNvSpPr txBox="1"/>
           <p:nvPr/>
         </p:nvSpPr>
@@ -2494,7 +2618,7 @@
       </p:sp>
       <p:sp>
         <p:nvSpPr>
-          <p:cNvPr id="14" name="Text 11"/>
+          <p:cNvPr id="14" name="Text 12"/>
           <p:cNvSpPr txBox="1"/>
           <p:nvPr/>
         </p:nvSpPr>
@@ -2533,7 +2657,7 @@
       </p:sp>
       <p:sp>
         <p:nvSpPr>
-          <p:cNvPr id="15" name="Text 12"/>
+          <p:cNvPr id="15" name="Text 13"/>
           <p:cNvSpPr txBox="1"/>
           <p:nvPr/>
         </p:nvSpPr>
@@ -2611,7 +2735,7 @@
       </p:sp>
       <p:sp>
         <p:nvSpPr>
-          <p:cNvPr id="17" name="Text 14"/>
+          <p:cNvPr id="17" name="Text 15"/>
           <p:cNvSpPr txBox="1"/>
           <p:nvPr/>
         </p:nvSpPr>
@@ -2650,7 +2774,7 @@
       </p:sp>
       <p:sp>
         <p:nvSpPr>
-          <p:cNvPr id="18" name="Text 15"/>
+          <p:cNvPr id="18" name="Text 16"/>
           <p:cNvSpPr txBox="1"/>
           <p:nvPr/>
         </p:nvSpPr>
@@ -3029,7 +3153,7 @@
                 <a:ea typeface="Malgun Gothic" pitchFamily="34" charset="-122"/>
                 <a:cs typeface="Malgun Gothic" pitchFamily="34" charset="-120"/>
               </a:rPr>
-              <a:t>구조</a:t>
+              <a:t>그 사이 · 가입</a:t>
             </a:r>
             <a:endParaRPr lang="en-US" sz="1300" dirty="0"/>
           </a:p>
@@ -3068,7 +3192,7 @@
                 <a:ea typeface="Malgun Gothic" pitchFamily="34" charset="-122"/>
                 <a:cs typeface="Malgun Gothic" pitchFamily="34" charset="-120"/>
               </a:rPr>
-              <a:t>가입 폼이 은행·계좌·예금주부터 묻는다</a:t>
+              <a:t>은행·계좌·예금주부터 묻는다 — 들어가면 충전까지 한 걸음</a:t>
             </a:r>
             <a:endParaRPr lang="en-US" sz="1100" dirty="0"/>
           </a:p>
@@ -3900,7 +4024,7 @@
         <p:spPr>
           <a:xfrm>
             <a:off x="5897880" y="2240280"/>
-            <a:ext cx="2651760" cy="1097280"/>
+            <a:ext cx="2651760" cy="868680"/>
           </a:xfrm>
           <a:prstGeom prst="rect">
             <a:avLst/>
@@ -3984,8 +4108,47 @@
         </p:nvSpPr>
         <p:spPr>
           <a:xfrm>
-            <a:off x="5897880" y="3474720"/>
-            <a:ext cx="2651760" cy="731520"/>
+            <a:off x="5897880" y="3154680"/>
+            <a:ext cx="2651760" cy="320040"/>
+          </a:xfrm>
+          <a:prstGeom prst="rect">
+            <a:avLst/>
+          </a:prstGeom>
+          <a:noFill/>
+          <a:ln/>
+        </p:spPr>
+        <p:txBody>
+          <a:bodyPr wrap="square" lIns="0" tIns="0" rIns="0" bIns="0" rtlCol="0" anchor="ctr"/>
+          <a:lstStyle/>
+          <a:p>
+            <a:pPr indent="0" marL="0">
+              <a:buNone/>
+            </a:pPr>
+            <a:r>
+              <a:rPr lang="en-US" sz="1150" dirty="0">
+                <a:solidFill>
+                  <a:schemeClr val="accent1"/>
+                </a:solidFill>
+                <a:latin typeface="Malgun Gothic" pitchFamily="34" charset="0"/>
+                <a:ea typeface="Malgun Gothic" pitchFamily="34" charset="-122"/>
+                <a:cs typeface="Malgun Gothic" pitchFamily="34" charset="-120"/>
+              </a:rPr>
+              <a:t>채우는 방법 → 화면을 읽어 판정한다 (7장)</a:t>
+            </a:r>
+            <a:endParaRPr lang="en-US" sz="1150" dirty="0"/>
+          </a:p>
+        </p:txBody>
+      </p:sp>
+      <p:sp>
+        <p:nvSpPr>
+          <p:cNvPr id="23" name="Text 17"/>
+          <p:cNvSpPr txBox="1"/>
+          <p:nvPr/>
+        </p:nvSpPr>
+        <p:spPr>
+          <a:xfrm>
+            <a:off x="5897880" y="3520440"/>
+            <a:ext cx="2651760" cy="777240"/>
           </a:xfrm>
           <a:prstGeom prst="rect">
             <a:avLst/>
@@ -4001,7 +4164,7 @@
               <a:buNone/>
             </a:pPr>
             <a:r>
-              <a:rPr lang="en-US" sz="1200" dirty="0">
+              <a:rPr lang="en-US" sz="1150" dirty="0">
                 <a:solidFill>
                   <a:schemeClr val="accent3"/>
                 </a:solidFill>
@@ -4009,9 +4172,9 @@
                 <a:ea typeface="Malgun Gothic" pitchFamily="34" charset="-122"/>
                 <a:cs typeface="Malgun Gothic" pitchFamily="34" charset="-120"/>
               </a:rPr>
-              <a:t>→ 화면 내용(OCR + 이미지)으로 판정하는 온디바이스 모델</a:t>
-            </a:r>
-            <a:endParaRPr lang="en-US" sz="1200" dirty="0"/>
+              <a:t>따로 깔게 하지 않는다 — 이미 쓰는 보안 앱의 '내 폰 보호' 기능 안에 넣어 설치 장벽을 없앤다</a:t>
+            </a:r>
+            <a:endParaRPr lang="en-US" sz="1150" dirty="0"/>
           </a:p>
         </p:txBody>
       </p:sp>
@@ -4423,7 +4586,24 @@
                 <a:ea typeface="Malgun Gothic" pitchFamily="34" charset="-122"/>
                 <a:cs typeface="Malgun Gothic" pitchFamily="34" charset="-120"/>
               </a:rPr>
-              <a:t>충전 직전 30초 + 지금까지 잃은 돈</a:t>
+              <a:t>충전 직전 30초 + 잃은 돈 합계</a:t>
+            </a:r>
+            <a:endParaRPr lang="en-US" sz="1000" dirty="0"/>
+          </a:p>
+          <a:p>
+            <a:pPr algn="ctr" indent="0" marL="0">
+              <a:buNone/>
+            </a:pPr>
+            <a:r>
+              <a:rPr lang="en-US" sz="1000" dirty="0">
+                <a:solidFill>
+                  <a:schemeClr val="tx2"/>
+                </a:solidFill>
+                <a:latin typeface="Malgun Gothic" pitchFamily="34" charset="0"/>
+                <a:ea typeface="Malgun Gothic" pitchFamily="34" charset="-122"/>
+                <a:cs typeface="Malgun Gothic" pitchFamily="34" charset="-120"/>
+              </a:rPr>
+              <a:t>(온보딩 때 본인 입력 + 충전 누적)</a:t>
             </a:r>
             <a:endParaRPr lang="en-US" sz="1000" dirty="0"/>
           </a:p>
@@ -5256,7 +5436,7 @@
                 <a:ea typeface="Malgun Gothic" pitchFamily="34" charset="-122"/>
                 <a:cs typeface="Malgun Gothic" pitchFamily="34" charset="-120"/>
               </a:rPr>
-              <a:t>새 주소는 못 막고 정상 게임까지 막아 삭제로 끝났다(AS-IS 4)</a:t>
+              <a:t>새 주소는 못 막고 정상 게임까지 막아, 결국 지워진다</a:t>
             </a:r>
             <a:endParaRPr lang="en-US" sz="1100" dirty="0"/>
           </a:p>
@@ -5608,7 +5788,7 @@
                   <a:schemeClr val="tx1"/>
                 </a:solidFill>
               </a:rPr>
-              <a:t>무엇으로 성공을 재나 · 앞으로의 일정</a:t>
+              <a:t>폰이 어떻게 아는가 · 주소가 아니라 화면을 읽는다</a:t>
             </a:r>
             <a:endParaRPr lang="en-US" sz="2400" dirty="0"/>
           </a:p>
@@ -5616,18 +5796,57 @@
       </p:sp>
       <p:sp>
         <p:nvSpPr>
-          <p:cNvPr id="3" name="kpi 1"/>
+          <p:cNvPr id="3" name="analogy"/>
+          <p:cNvSpPr txBox="1"/>
+          <p:nvPr/>
+        </p:nvSpPr>
+        <p:spPr>
+          <a:xfrm>
+            <a:off x="457200" y="914400"/>
+            <a:ext cx="8229600" cy="320040"/>
+          </a:xfrm>
+          <a:prstGeom prst="rect">
+            <a:avLst/>
+          </a:prstGeom>
+          <a:noFill/>
+          <a:ln/>
+        </p:spPr>
+        <p:txBody>
+          <a:bodyPr wrap="square" lIns="0" tIns="0" rIns="0" bIns="0" rtlCol="0" anchor="ctr"/>
+          <a:lstStyle/>
+          <a:p>
+            <a:pPr indent="0" marL="0">
+              <a:buNone/>
+            </a:pPr>
+            <a:r>
+              <a:rPr lang="en-US" sz="1300" dirty="0">
+                <a:solidFill>
+                  <a:schemeClr val="tx2"/>
+                </a:solidFill>
+                <a:latin typeface="Malgun Gothic" pitchFamily="34" charset="0"/>
+                <a:ea typeface="Malgun Gothic" pitchFamily="34" charset="-122"/>
+                <a:cs typeface="Malgun Gothic" pitchFamily="34" charset="-120"/>
+              </a:rPr>
+              <a:t>간판(주소)은 매일 바뀌지만 가게 안(화면)은 똑같다 — 그래서 주소 목록이 아니라 화면을 본다</a:t>
+            </a:r>
+            <a:endParaRPr lang="en-US" sz="1300" dirty="0"/>
+          </a:p>
+        </p:txBody>
+      </p:sp>
+      <p:sp>
+        <p:nvSpPr>
+          <p:cNvPr id="4" name="flow 1"/>
           <p:cNvSpPr/>
           <p:nvPr/>
         </p:nvSpPr>
         <p:spPr>
           <a:xfrm>
-            <a:off x="457200" y="1005840"/>
-            <a:ext cx="2011680" cy="896112"/>
+            <a:off x="457200" y="1371600"/>
+            <a:ext cx="1143000" cy="685800"/>
           </a:xfrm>
           <a:prstGeom prst="roundRect">
             <a:avLst>
-              <a:gd name="adj" fmla="val 8163"/>
+              <a:gd name="adj" fmla="val 10667"/>
             </a:avLst>
           </a:prstGeom>
           <a:solidFill>
@@ -5638,14 +5857,14 @@
       </p:sp>
       <p:sp>
         <p:nvSpPr>
-          <p:cNvPr id="4" name="Text 2"/>
-          <p:cNvSpPr txBox="1"/>
-          <p:nvPr/>
-        </p:nvSpPr>
-        <p:spPr>
-          <a:xfrm>
-            <a:off x="621792" y="1097280"/>
-            <a:ext cx="1737360" cy="457200"/>
+          <p:cNvPr id="5" name="Text 3"/>
+          <p:cNvSpPr txBox="1"/>
+          <p:nvPr/>
+        </p:nvSpPr>
+        <p:spPr>
+          <a:xfrm>
+            <a:off x="457200" y="1371600"/>
+            <a:ext cx="1143000" cy="685800"/>
           </a:xfrm>
           <a:prstGeom prst="rect">
             <a:avLst/>
@@ -5657,11 +5876,11 @@
           <a:bodyPr wrap="square" lIns="0" tIns="0" rIns="0" bIns="0" rtlCol="0" anchor="ctr"/>
           <a:lstStyle/>
           <a:p>
-            <a:pPr indent="0" marL="0">
-              <a:buNone/>
-            </a:pPr>
-            <a:r>
-              <a:rPr lang="en-US" sz="2200" b="1" dirty="0">
+            <a:pPr algn="ctr" indent="0" marL="0">
+              <a:buNone/>
+            </a:pPr>
+            <a:r>
+              <a:rPr lang="en-US" sz="1100" b="1" dirty="0">
                 <a:solidFill>
                   <a:schemeClr val="tx1"/>
                 </a:solidFill>
@@ -5669,22 +5888,22 @@
                 <a:ea typeface="Malgun Gothic" pitchFamily="34" charset="-122"/>
                 <a:cs typeface="Malgun Gothic" pitchFamily="34" charset="-120"/>
               </a:rPr>
-              <a:t>0.90</a:t>
-            </a:r>
-            <a:endParaRPr lang="en-US" sz="2200" dirty="0"/>
-          </a:p>
-        </p:txBody>
-      </p:sp>
-      <p:sp>
-        <p:nvSpPr>
-          <p:cNvPr id="5" name="Text 3"/>
-          <p:cNvSpPr txBox="1"/>
-          <p:nvPr/>
-        </p:nvSpPr>
-        <p:spPr>
-          <a:xfrm>
-            <a:off x="621792" y="1554480"/>
-            <a:ext cx="1783080" cy="274320"/>
+              <a:t>화면 캡처</a:t>
+            </a:r>
+            <a:endParaRPr lang="en-US" sz="1100" dirty="0"/>
+          </a:p>
+        </p:txBody>
+      </p:sp>
+      <p:sp>
+        <p:nvSpPr>
+          <p:cNvPr id="6" name="Text 4"/>
+          <p:cNvSpPr txBox="1"/>
+          <p:nvPr/>
+        </p:nvSpPr>
+        <p:spPr>
+          <a:xfrm>
+            <a:off x="1600200" y="1371600"/>
+            <a:ext cx="274320" cy="685800"/>
           </a:xfrm>
           <a:prstGeom prst="rect">
             <a:avLst/>
@@ -5696,38 +5915,38 @@
           <a:bodyPr wrap="square" lIns="0" tIns="0" rIns="0" bIns="0" rtlCol="0" anchor="ctr"/>
           <a:lstStyle/>
           <a:p>
-            <a:pPr indent="0" marL="0">
-              <a:buNone/>
-            </a:pPr>
-            <a:r>
-              <a:rPr lang="en-US" sz="1100" dirty="0">
-                <a:solidFill>
-                  <a:schemeClr val="tx2"/>
-                </a:solidFill>
-                <a:latin typeface="Malgun Gothic" pitchFamily="34" charset="0"/>
-                <a:ea typeface="Malgun Gothic" pitchFamily="34" charset="-122"/>
-                <a:cs typeface="Malgun Gothic" pitchFamily="34" charset="-120"/>
-              </a:rPr>
-              <a:t>융합 모델 F1</a:t>
-            </a:r>
-            <a:endParaRPr lang="en-US" sz="1100" dirty="0"/>
-          </a:p>
-        </p:txBody>
-      </p:sp>
-      <p:sp>
-        <p:nvSpPr>
-          <p:cNvPr id="6" name="kpi 2"/>
+            <a:pPr algn="ctr" indent="0" marL="0">
+              <a:buNone/>
+            </a:pPr>
+            <a:r>
+              <a:rPr lang="en-US" sz="1400" dirty="0">
+                <a:solidFill>
+                  <a:schemeClr val="accent2"/>
+                </a:solidFill>
+                <a:latin typeface="Malgun Gothic" pitchFamily="34" charset="0"/>
+                <a:ea typeface="Malgun Gothic" pitchFamily="34" charset="-122"/>
+                <a:cs typeface="Malgun Gothic" pitchFamily="34" charset="-120"/>
+              </a:rPr>
+              <a:t>→</a:t>
+            </a:r>
+            <a:endParaRPr lang="en-US" sz="1400" dirty="0"/>
+          </a:p>
+        </p:txBody>
+      </p:sp>
+      <p:sp>
+        <p:nvSpPr>
+          <p:cNvPr id="7" name="flow 2"/>
           <p:cNvSpPr/>
           <p:nvPr/>
         </p:nvSpPr>
         <p:spPr>
           <a:xfrm>
-            <a:off x="2606040" y="1005840"/>
-            <a:ext cx="2011680" cy="896112"/>
+            <a:off x="1874520" y="1371600"/>
+            <a:ext cx="1143000" cy="685800"/>
           </a:xfrm>
           <a:prstGeom prst="roundRect">
             <a:avLst>
-              <a:gd name="adj" fmla="val 8163"/>
+              <a:gd name="adj" fmla="val 10667"/>
             </a:avLst>
           </a:prstGeom>
           <a:solidFill>
@@ -5738,14 +5957,14 @@
       </p:sp>
       <p:sp>
         <p:nvSpPr>
-          <p:cNvPr id="7" name="Text 5"/>
-          <p:cNvSpPr txBox="1"/>
-          <p:nvPr/>
-        </p:nvSpPr>
-        <p:spPr>
-          <a:xfrm>
-            <a:off x="2770632" y="1097280"/>
-            <a:ext cx="1737360" cy="457200"/>
+          <p:cNvPr id="8" name="Text 6"/>
+          <p:cNvSpPr txBox="1"/>
+          <p:nvPr/>
+        </p:nvSpPr>
+        <p:spPr>
+          <a:xfrm>
+            <a:off x="1874520" y="1371600"/>
+            <a:ext cx="1143000" cy="685800"/>
           </a:xfrm>
           <a:prstGeom prst="rect">
             <a:avLst/>
@@ -5757,11 +5976,11 @@
           <a:bodyPr wrap="square" lIns="0" tIns="0" rIns="0" bIns="0" rtlCol="0" anchor="ctr"/>
           <a:lstStyle/>
           <a:p>
-            <a:pPr indent="0" marL="0">
-              <a:buNone/>
-            </a:pPr>
-            <a:r>
-              <a:rPr lang="en-US" sz="2200" b="1" dirty="0">
+            <a:pPr algn="ctr" indent="0" marL="0">
+              <a:buNone/>
+            </a:pPr>
+            <a:r>
+              <a:rPr lang="en-US" sz="1100" b="1" dirty="0">
                 <a:solidFill>
                   <a:schemeClr val="tx1"/>
                 </a:solidFill>
@@ -5769,22 +5988,39 @@
                 <a:ea typeface="Malgun Gothic" pitchFamily="34" charset="-122"/>
                 <a:cs typeface="Malgun Gothic" pitchFamily="34" charset="-120"/>
               </a:rPr>
-              <a:t>≤ 2%</a:t>
-            </a:r>
-            <a:endParaRPr lang="en-US" sz="2200" dirty="0"/>
-          </a:p>
-        </p:txBody>
-      </p:sp>
-      <p:sp>
-        <p:nvSpPr>
-          <p:cNvPr id="8" name="Text 6"/>
-          <p:cNvSpPr txBox="1"/>
-          <p:nvPr/>
-        </p:nvSpPr>
-        <p:spPr>
-          <a:xfrm>
-            <a:off x="2770632" y="1554480"/>
-            <a:ext cx="1783080" cy="274320"/>
+              <a:t>글자 읽기</a:t>
+            </a:r>
+            <a:endParaRPr lang="en-US" sz="1100" dirty="0"/>
+          </a:p>
+          <a:p>
+            <a:pPr algn="ctr" indent="0" marL="0">
+              <a:buNone/>
+            </a:pPr>
+            <a:r>
+              <a:rPr lang="en-US" sz="1100" b="1" dirty="0">
+                <a:solidFill>
+                  <a:schemeClr val="tx1"/>
+                </a:solidFill>
+                <a:latin typeface="Malgun Gothic" pitchFamily="34" charset="0"/>
+                <a:ea typeface="Malgun Gothic" pitchFamily="34" charset="-122"/>
+                <a:cs typeface="Malgun Gothic" pitchFamily="34" charset="-120"/>
+              </a:rPr>
+              <a:t>+ 생김새 보기</a:t>
+            </a:r>
+            <a:endParaRPr lang="en-US" sz="1100" dirty="0"/>
+          </a:p>
+        </p:txBody>
+      </p:sp>
+      <p:sp>
+        <p:nvSpPr>
+          <p:cNvPr id="9" name="Text 7"/>
+          <p:cNvSpPr txBox="1"/>
+          <p:nvPr/>
+        </p:nvSpPr>
+        <p:spPr>
+          <a:xfrm>
+            <a:off x="3017520" y="1371600"/>
+            <a:ext cx="274320" cy="685800"/>
           </a:xfrm>
           <a:prstGeom prst="rect">
             <a:avLst/>
@@ -5796,38 +6032,155 @@
           <a:bodyPr wrap="square" lIns="0" tIns="0" rIns="0" bIns="0" rtlCol="0" anchor="ctr"/>
           <a:lstStyle/>
           <a:p>
-            <a:pPr indent="0" marL="0">
-              <a:buNone/>
-            </a:pPr>
-            <a:r>
-              <a:rPr lang="en-US" sz="1100" dirty="0">
-                <a:solidFill>
-                  <a:schemeClr val="tx2"/>
-                </a:solidFill>
-                <a:latin typeface="Malgun Gothic" pitchFamily="34" charset="0"/>
-                <a:ea typeface="Malgun Gothic" pitchFamily="34" charset="-122"/>
-                <a:cs typeface="Malgun Gothic" pitchFamily="34" charset="-120"/>
-              </a:rPr>
-              <a:t>정상 게임·결제 오탐률</a:t>
-            </a:r>
-            <a:endParaRPr lang="en-US" sz="1100" dirty="0"/>
-          </a:p>
-        </p:txBody>
-      </p:sp>
-      <p:sp>
-        <p:nvSpPr>
-          <p:cNvPr id="9" name="kpi 3"/>
+            <a:pPr algn="ctr" indent="0" marL="0">
+              <a:buNone/>
+            </a:pPr>
+            <a:r>
+              <a:rPr lang="en-US" sz="1400" dirty="0">
+                <a:solidFill>
+                  <a:schemeClr val="accent2"/>
+                </a:solidFill>
+                <a:latin typeface="Malgun Gothic" pitchFamily="34" charset="0"/>
+                <a:ea typeface="Malgun Gothic" pitchFamily="34" charset="-122"/>
+                <a:cs typeface="Malgun Gothic" pitchFamily="34" charset="-120"/>
+              </a:rPr>
+              <a:t>→</a:t>
+            </a:r>
+            <a:endParaRPr lang="en-US" sz="1400" dirty="0"/>
+          </a:p>
+        </p:txBody>
+      </p:sp>
+      <p:sp>
+        <p:nvSpPr>
+          <p:cNvPr id="10" name="flow 3"/>
           <p:cNvSpPr/>
           <p:nvPr/>
         </p:nvSpPr>
         <p:spPr>
           <a:xfrm>
-            <a:off x="457200" y="2029968"/>
-            <a:ext cx="2011680" cy="896112"/>
+            <a:off x="3291840" y="1371600"/>
+            <a:ext cx="1143000" cy="685800"/>
           </a:xfrm>
           <a:prstGeom prst="roundRect">
             <a:avLst>
-              <a:gd name="adj" fmla="val 8163"/>
+              <a:gd name="adj" fmla="val 10667"/>
+            </a:avLst>
+          </a:prstGeom>
+          <a:solidFill>
+            <a:srgbClr val="C6F135"/>
+          </a:solidFill>
+          <a:ln/>
+        </p:spPr>
+      </p:sp>
+      <p:sp>
+        <p:nvSpPr>
+          <p:cNvPr id="11" name="Text 9"/>
+          <p:cNvSpPr txBox="1"/>
+          <p:nvPr/>
+        </p:nvSpPr>
+        <p:spPr>
+          <a:xfrm>
+            <a:off x="3291840" y="1371600"/>
+            <a:ext cx="1143000" cy="685800"/>
+          </a:xfrm>
+          <a:prstGeom prst="rect">
+            <a:avLst/>
+          </a:prstGeom>
+          <a:noFill/>
+          <a:ln/>
+        </p:spPr>
+        <p:txBody>
+          <a:bodyPr wrap="square" lIns="0" tIns="0" rIns="0" bIns="0" rtlCol="0" anchor="ctr"/>
+          <a:lstStyle/>
+          <a:p>
+            <a:pPr algn="ctr" indent="0" marL="0">
+              <a:buNone/>
+            </a:pPr>
+            <a:r>
+              <a:rPr lang="en-US" sz="1100" b="1" dirty="0">
+                <a:solidFill>
+                  <a:schemeClr val="tx1"/>
+                </a:solidFill>
+                <a:latin typeface="Malgun Gothic" pitchFamily="34" charset="0"/>
+                <a:ea typeface="Malgun Gothic" pitchFamily="34" charset="-122"/>
+                <a:cs typeface="Malgun Gothic" pitchFamily="34" charset="-120"/>
+              </a:rPr>
+              <a:t>도박 화면?</a:t>
+            </a:r>
+            <a:endParaRPr lang="en-US" sz="1100" dirty="0"/>
+          </a:p>
+          <a:p>
+            <a:pPr algn="ctr" indent="0" marL="0">
+              <a:buNone/>
+            </a:pPr>
+            <a:r>
+              <a:rPr lang="en-US" sz="1100" b="1" dirty="0">
+                <a:solidFill>
+                  <a:schemeClr val="tx1"/>
+                </a:solidFill>
+                <a:latin typeface="Malgun Gothic" pitchFamily="34" charset="0"/>
+                <a:ea typeface="Malgun Gothic" pitchFamily="34" charset="-122"/>
+                <a:cs typeface="Malgun Gothic" pitchFamily="34" charset="-120"/>
+              </a:rPr>
+              <a:t>충전 화면?</a:t>
+            </a:r>
+            <a:endParaRPr lang="en-US" sz="1100" dirty="0"/>
+          </a:p>
+        </p:txBody>
+      </p:sp>
+      <p:sp>
+        <p:nvSpPr>
+          <p:cNvPr id="12" name="Text 10"/>
+          <p:cNvSpPr txBox="1"/>
+          <p:nvPr/>
+        </p:nvSpPr>
+        <p:spPr>
+          <a:xfrm>
+            <a:off x="4434840" y="1371600"/>
+            <a:ext cx="274320" cy="685800"/>
+          </a:xfrm>
+          <a:prstGeom prst="rect">
+            <a:avLst/>
+          </a:prstGeom>
+          <a:noFill/>
+          <a:ln/>
+        </p:spPr>
+        <p:txBody>
+          <a:bodyPr wrap="square" lIns="0" tIns="0" rIns="0" bIns="0" rtlCol="0" anchor="ctr"/>
+          <a:lstStyle/>
+          <a:p>
+            <a:pPr algn="ctr" indent="0" marL="0">
+              <a:buNone/>
+            </a:pPr>
+            <a:r>
+              <a:rPr lang="en-US" sz="1400" dirty="0">
+                <a:solidFill>
+                  <a:schemeClr val="accent2"/>
+                </a:solidFill>
+                <a:latin typeface="Malgun Gothic" pitchFamily="34" charset="0"/>
+                <a:ea typeface="Malgun Gothic" pitchFamily="34" charset="-122"/>
+                <a:cs typeface="Malgun Gothic" pitchFamily="34" charset="-120"/>
+              </a:rPr>
+              <a:t>→</a:t>
+            </a:r>
+            <a:endParaRPr lang="en-US" sz="1400" dirty="0"/>
+          </a:p>
+        </p:txBody>
+      </p:sp>
+      <p:sp>
+        <p:nvSpPr>
+          <p:cNvPr id="13" name="flow 4"/>
+          <p:cNvSpPr/>
+          <p:nvPr/>
+        </p:nvSpPr>
+        <p:spPr>
+          <a:xfrm>
+            <a:off x="4709160" y="1371600"/>
+            <a:ext cx="1143000" cy="685800"/>
+          </a:xfrm>
+          <a:prstGeom prst="roundRect">
+            <a:avLst>
+              <a:gd name="adj" fmla="val 10667"/>
             </a:avLst>
           </a:prstGeom>
           <a:solidFill>
@@ -5838,14 +6191,14 @@
       </p:sp>
       <p:sp>
         <p:nvSpPr>
-          <p:cNvPr id="10" name="Text 8"/>
-          <p:cNvSpPr txBox="1"/>
-          <p:nvPr/>
-        </p:nvSpPr>
-        <p:spPr>
-          <a:xfrm>
-            <a:off x="621792" y="2121408"/>
-            <a:ext cx="1737360" cy="457200"/>
+          <p:cNvPr id="14" name="Text 12"/>
+          <p:cNvSpPr txBox="1"/>
+          <p:nvPr/>
+        </p:nvSpPr>
+        <p:spPr>
+          <a:xfrm>
+            <a:off x="4709160" y="1371600"/>
+            <a:ext cx="1143000" cy="685800"/>
           </a:xfrm>
           <a:prstGeom prst="rect">
             <a:avLst/>
@@ -5857,11 +6210,11 @@
           <a:bodyPr wrap="square" lIns="0" tIns="0" rIns="0" bIns="0" rtlCol="0" anchor="ctr"/>
           <a:lstStyle/>
           <a:p>
-            <a:pPr indent="0" marL="0">
-              <a:buNone/>
-            </a:pPr>
-            <a:r>
-              <a:rPr lang="en-US" sz="2200" b="1" dirty="0">
+            <a:pPr algn="ctr" indent="0" marL="0">
+              <a:buNone/>
+            </a:pPr>
+            <a:r>
+              <a:rPr lang="en-US" sz="1100" b="1" dirty="0">
                 <a:solidFill>
                   <a:schemeClr val="tx1"/>
                 </a:solidFill>
@@ -5869,22 +6222,39 @@
                 <a:ea typeface="Malgun Gothic" pitchFamily="34" charset="-122"/>
                 <a:cs typeface="Malgun Gothic" pitchFamily="34" charset="-120"/>
               </a:rPr>
-              <a:t>0.90</a:t>
-            </a:r>
-            <a:endParaRPr lang="en-US" sz="2200" dirty="0"/>
-          </a:p>
-        </p:txBody>
-      </p:sp>
-      <p:sp>
-        <p:nvSpPr>
-          <p:cNvPr id="11" name="Text 9"/>
-          <p:cNvSpPr txBox="1"/>
-          <p:nvPr/>
-        </p:nvSpPr>
-        <p:spPr>
-          <a:xfrm>
-            <a:off x="621792" y="2578608"/>
-            <a:ext cx="1783080" cy="274320"/>
+              <a:t>약속 카드</a:t>
+            </a:r>
+            <a:endParaRPr lang="en-US" sz="1100" dirty="0"/>
+          </a:p>
+          <a:p>
+            <a:pPr algn="ctr" indent="0" marL="0">
+              <a:buNone/>
+            </a:pPr>
+            <a:r>
+              <a:rPr lang="en-US" sz="1100" b="1" dirty="0">
+                <a:solidFill>
+                  <a:schemeClr val="tx1"/>
+                </a:solidFill>
+                <a:latin typeface="Malgun Gothic" pitchFamily="34" charset="0"/>
+                <a:ea typeface="Malgun Gothic" pitchFamily="34" charset="-122"/>
+                <a:cs typeface="Malgun Gothic" pitchFamily="34" charset="-120"/>
+              </a:rPr>
+              <a:t>/ 쿨다운</a:t>
+            </a:r>
+            <a:endParaRPr lang="en-US" sz="1100" dirty="0"/>
+          </a:p>
+        </p:txBody>
+      </p:sp>
+      <p:sp>
+        <p:nvSpPr>
+          <p:cNvPr id="15" name="Text 13"/>
+          <p:cNvSpPr txBox="1"/>
+          <p:nvPr/>
+        </p:nvSpPr>
+        <p:spPr>
+          <a:xfrm>
+            <a:off x="5852160" y="1371600"/>
+            <a:ext cx="274320" cy="685800"/>
           </a:xfrm>
           <a:prstGeom prst="rect">
             <a:avLst/>
@@ -5896,138 +6266,38 @@
           <a:bodyPr wrap="square" lIns="0" tIns="0" rIns="0" bIns="0" rtlCol="0" anchor="ctr"/>
           <a:lstStyle/>
           <a:p>
-            <a:pPr indent="0" marL="0">
-              <a:buNone/>
-            </a:pPr>
-            <a:r>
-              <a:rPr lang="en-US" sz="1100" dirty="0">
-                <a:solidFill>
-                  <a:schemeClr val="tx2"/>
-                </a:solidFill>
-                <a:latin typeface="Malgun Gothic" pitchFamily="34" charset="0"/>
-                <a:ea typeface="Malgun Gothic" pitchFamily="34" charset="-122"/>
-                <a:cs typeface="Malgun Gothic" pitchFamily="34" charset="-120"/>
-              </a:rPr>
-              <a:t>충전 직전 화면 재현율</a:t>
-            </a:r>
-            <a:endParaRPr lang="en-US" sz="1100" dirty="0"/>
-          </a:p>
-        </p:txBody>
-      </p:sp>
-      <p:sp>
-        <p:nvSpPr>
-          <p:cNvPr id="12" name="kpi 4"/>
+            <a:pPr algn="ctr" indent="0" marL="0">
+              <a:buNone/>
+            </a:pPr>
+            <a:r>
+              <a:rPr lang="en-US" sz="1400" dirty="0">
+                <a:solidFill>
+                  <a:schemeClr val="accent2"/>
+                </a:solidFill>
+                <a:latin typeface="Malgun Gothic" pitchFamily="34" charset="0"/>
+                <a:ea typeface="Malgun Gothic" pitchFamily="34" charset="-122"/>
+                <a:cs typeface="Malgun Gothic" pitchFamily="34" charset="-120"/>
+              </a:rPr>
+              <a:t>→</a:t>
+            </a:r>
+            <a:endParaRPr lang="en-US" sz="1400" dirty="0"/>
+          </a:p>
+        </p:txBody>
+      </p:sp>
+      <p:sp>
+        <p:nvSpPr>
+          <p:cNvPr id="16" name="flow 5"/>
           <p:cNvSpPr/>
           <p:nvPr/>
         </p:nvSpPr>
         <p:spPr>
           <a:xfrm>
-            <a:off x="2606040" y="2029968"/>
-            <a:ext cx="2011680" cy="896112"/>
+            <a:off x="6126480" y="1371600"/>
+            <a:ext cx="1143000" cy="685800"/>
           </a:xfrm>
           <a:prstGeom prst="roundRect">
             <a:avLst>
-              <a:gd name="adj" fmla="val 8163"/>
-            </a:avLst>
-          </a:prstGeom>
-          <a:solidFill>
-            <a:srgbClr val="EEF9C6"/>
-          </a:solidFill>
-          <a:ln/>
-        </p:spPr>
-      </p:sp>
-      <p:sp>
-        <p:nvSpPr>
-          <p:cNvPr id="13" name="Text 11"/>
-          <p:cNvSpPr txBox="1"/>
-          <p:nvPr/>
-        </p:nvSpPr>
-        <p:spPr>
-          <a:xfrm>
-            <a:off x="2770632" y="2121408"/>
-            <a:ext cx="1737360" cy="457200"/>
-          </a:xfrm>
-          <a:prstGeom prst="rect">
-            <a:avLst/>
-          </a:prstGeom>
-          <a:noFill/>
-          <a:ln/>
-        </p:spPr>
-        <p:txBody>
-          <a:bodyPr wrap="square" lIns="0" tIns="0" rIns="0" bIns="0" rtlCol="0" anchor="ctr"/>
-          <a:lstStyle/>
-          <a:p>
-            <a:pPr indent="0" marL="0">
-              <a:buNone/>
-            </a:pPr>
-            <a:r>
-              <a:rPr lang="en-US" sz="2200" b="1" dirty="0">
-                <a:solidFill>
-                  <a:schemeClr val="tx1"/>
-                </a:solidFill>
-                <a:latin typeface="Malgun Gothic" pitchFamily="34" charset="0"/>
-                <a:ea typeface="Malgun Gothic" pitchFamily="34" charset="-122"/>
-                <a:cs typeface="Malgun Gothic" pitchFamily="34" charset="-120"/>
-              </a:rPr>
-              <a:t>70%</a:t>
-            </a:r>
-            <a:endParaRPr lang="en-US" sz="2200" dirty="0"/>
-          </a:p>
-        </p:txBody>
-      </p:sp>
-      <p:sp>
-        <p:nvSpPr>
-          <p:cNvPr id="14" name="Text 12"/>
-          <p:cNvSpPr txBox="1"/>
-          <p:nvPr/>
-        </p:nvSpPr>
-        <p:spPr>
-          <a:xfrm>
-            <a:off x="2770632" y="2578608"/>
-            <a:ext cx="1783080" cy="274320"/>
-          </a:xfrm>
-          <a:prstGeom prst="rect">
-            <a:avLst/>
-          </a:prstGeom>
-          <a:noFill/>
-          <a:ln/>
-        </p:spPr>
-        <p:txBody>
-          <a:bodyPr wrap="square" lIns="0" tIns="0" rIns="0" bIns="0" rtlCol="0" anchor="ctr"/>
-          <a:lstStyle/>
-          <a:p>
-            <a:pPr indent="0" marL="0">
-              <a:buNone/>
-            </a:pPr>
-            <a:r>
-              <a:rPr lang="en-US" sz="1100" dirty="0">
-                <a:solidFill>
-                  <a:schemeClr val="tx2"/>
-                </a:solidFill>
-                <a:latin typeface="Malgun Gothic" pitchFamily="34" charset="0"/>
-                <a:ea typeface="Malgun Gothic" pitchFamily="34" charset="-122"/>
-                <a:cs typeface="Malgun Gothic" pitchFamily="34" charset="-120"/>
-              </a:rPr>
-              <a:t>쿨다운에서 '나가기' 선택</a:t>
-            </a:r>
-            <a:endParaRPr lang="en-US" sz="1100" dirty="0"/>
-          </a:p>
-        </p:txBody>
-      </p:sp>
-      <p:sp>
-        <p:nvSpPr>
-          <p:cNvPr id="15" name="kpi 5"/>
-          <p:cNvSpPr/>
-          <p:nvPr/>
-        </p:nvSpPr>
-        <p:spPr>
-          <a:xfrm>
-            <a:off x="457200" y="3054096"/>
-            <a:ext cx="2011680" cy="896112"/>
-          </a:xfrm>
-          <a:prstGeom prst="roundRect">
-            <a:avLst>
-              <a:gd name="adj" fmla="val 8163"/>
+              <a:gd name="adj" fmla="val 10667"/>
             </a:avLst>
           </a:prstGeom>
           <a:solidFill>
@@ -6038,14 +6308,14 @@
       </p:sp>
       <p:sp>
         <p:nvSpPr>
-          <p:cNvPr id="16" name="Text 14"/>
-          <p:cNvSpPr txBox="1"/>
-          <p:nvPr/>
-        </p:nvSpPr>
-        <p:spPr>
-          <a:xfrm>
-            <a:off x="621792" y="3145536"/>
-            <a:ext cx="1737360" cy="457200"/>
+          <p:cNvPr id="17" name="Text 15"/>
+          <p:cNvSpPr txBox="1"/>
+          <p:nvPr/>
+        </p:nvSpPr>
+        <p:spPr>
+          <a:xfrm>
+            <a:off x="6126480" y="1371600"/>
+            <a:ext cx="1143000" cy="685800"/>
           </a:xfrm>
           <a:prstGeom prst="rect">
             <a:avLst/>
@@ -6057,11 +6327,11 @@
           <a:bodyPr wrap="square" lIns="0" tIns="0" rIns="0" bIns="0" rtlCol="0" anchor="ctr"/>
           <a:lstStyle/>
           <a:p>
-            <a:pPr indent="0" marL="0">
-              <a:buNone/>
-            </a:pPr>
-            <a:r>
-              <a:rPr lang="en-US" sz="2200" b="1" dirty="0">
+            <a:pPr algn="ctr" indent="0" marL="0">
+              <a:buNone/>
+            </a:pPr>
+            <a:r>
+              <a:rPr lang="en-US" sz="1100" b="1" dirty="0">
                 <a:solidFill>
                   <a:schemeClr val="tx1"/>
                 </a:solidFill>
@@ -6069,22 +6339,22 @@
                 <a:ea typeface="Malgun Gothic" pitchFamily="34" charset="-122"/>
                 <a:cs typeface="Malgun Gothic" pitchFamily="34" charset="-120"/>
               </a:rPr>
-              <a:t>1초 · 50MB</a:t>
-            </a:r>
-            <a:endParaRPr lang="en-US" sz="2200" dirty="0"/>
-          </a:p>
-        </p:txBody>
-      </p:sp>
-      <p:sp>
-        <p:nvSpPr>
-          <p:cNvPr id="17" name="Text 15"/>
-          <p:cNvSpPr txBox="1"/>
-          <p:nvPr/>
-        </p:nvSpPr>
-        <p:spPr>
-          <a:xfrm>
-            <a:off x="621792" y="3602736"/>
-            <a:ext cx="1783080" cy="274320"/>
+              <a:t>선택은 본인</a:t>
+            </a:r>
+            <a:endParaRPr lang="en-US" sz="1100" dirty="0"/>
+          </a:p>
+        </p:txBody>
+      </p:sp>
+      <p:sp>
+        <p:nvSpPr>
+          <p:cNvPr id="18" name="Text 16"/>
+          <p:cNvSpPr txBox="1"/>
+          <p:nvPr/>
+        </p:nvSpPr>
+        <p:spPr>
+          <a:xfrm>
+            <a:off x="7269480" y="1371600"/>
+            <a:ext cx="274320" cy="685800"/>
           </a:xfrm>
           <a:prstGeom prst="rect">
             <a:avLst/>
@@ -6096,38 +6366,38 @@
           <a:bodyPr wrap="square" lIns="0" tIns="0" rIns="0" bIns="0" rtlCol="0" anchor="ctr"/>
           <a:lstStyle/>
           <a:p>
-            <a:pPr indent="0" marL="0">
-              <a:buNone/>
-            </a:pPr>
-            <a:r>
-              <a:rPr lang="en-US" sz="1100" dirty="0">
-                <a:solidFill>
-                  <a:schemeClr val="tx2"/>
-                </a:solidFill>
-                <a:latin typeface="Malgun Gothic" pitchFamily="34" charset="0"/>
-                <a:ea typeface="Malgun Gothic" pitchFamily="34" charset="-122"/>
-                <a:cs typeface="Malgun Gothic" pitchFamily="34" charset="-120"/>
-              </a:rPr>
-              <a:t>온디바이스 추론·모델 크기</a:t>
-            </a:r>
-            <a:endParaRPr lang="en-US" sz="1100" dirty="0"/>
-          </a:p>
-        </p:txBody>
-      </p:sp>
-      <p:sp>
-        <p:nvSpPr>
-          <p:cNvPr id="18" name="kpi 6"/>
+            <a:pPr algn="ctr" indent="0" marL="0">
+              <a:buNone/>
+            </a:pPr>
+            <a:r>
+              <a:rPr lang="en-US" sz="1400" dirty="0">
+                <a:solidFill>
+                  <a:schemeClr val="accent2"/>
+                </a:solidFill>
+                <a:latin typeface="Malgun Gothic" pitchFamily="34" charset="0"/>
+                <a:ea typeface="Malgun Gothic" pitchFamily="34" charset="-122"/>
+                <a:cs typeface="Malgun Gothic" pitchFamily="34" charset="-120"/>
+              </a:rPr>
+              <a:t>→</a:t>
+            </a:r>
+            <a:endParaRPr lang="en-US" sz="1400" dirty="0"/>
+          </a:p>
+        </p:txBody>
+      </p:sp>
+      <p:sp>
+        <p:nvSpPr>
+          <p:cNvPr id="19" name="flow 6"/>
           <p:cNvSpPr/>
           <p:nvPr/>
         </p:nvSpPr>
         <p:spPr>
           <a:xfrm>
-            <a:off x="2606040" y="3054096"/>
-            <a:ext cx="2011680" cy="896112"/>
+            <a:off x="7543800" y="1371600"/>
+            <a:ext cx="1143000" cy="685800"/>
           </a:xfrm>
           <a:prstGeom prst="roundRect">
             <a:avLst>
-              <a:gd name="adj" fmla="val 8163"/>
+              <a:gd name="adj" fmla="val 10667"/>
             </a:avLst>
           </a:prstGeom>
           <a:solidFill>
@@ -6138,14 +6408,14 @@
       </p:sp>
       <p:sp>
         <p:nvSpPr>
-          <p:cNvPr id="19" name="Text 17"/>
-          <p:cNvSpPr txBox="1"/>
-          <p:nvPr/>
-        </p:nvSpPr>
-        <p:spPr>
-          <a:xfrm>
-            <a:off x="2770632" y="3145536"/>
-            <a:ext cx="1737360" cy="457200"/>
+          <p:cNvPr id="20" name="Text 18"/>
+          <p:cNvSpPr txBox="1"/>
+          <p:nvPr/>
+        </p:nvSpPr>
+        <p:spPr>
+          <a:xfrm>
+            <a:off x="7543800" y="1371600"/>
+            <a:ext cx="1143000" cy="685800"/>
           </a:xfrm>
           <a:prstGeom prst="rect">
             <a:avLst/>
@@ -6157,11 +6427,11 @@
           <a:bodyPr wrap="square" lIns="0" tIns="0" rIns="0" bIns="0" rtlCol="0" anchor="ctr"/>
           <a:lstStyle/>
           <a:p>
-            <a:pPr indent="0" marL="0">
-              <a:buNone/>
-            </a:pPr>
-            <a:r>
-              <a:rPr lang="en-US" sz="2200" b="1" dirty="0">
+            <a:pPr algn="ctr" indent="0" marL="0">
+              <a:buNone/>
+            </a:pPr>
+            <a:r>
+              <a:rPr lang="en-US" sz="1100" b="1" dirty="0">
                 <a:solidFill>
                   <a:schemeClr val="tx1"/>
                 </a:solidFill>
@@ -6169,46 +6439,7 @@
                 <a:ea typeface="Malgun Gothic" pitchFamily="34" charset="-122"/>
                 <a:cs typeface="Malgun Gothic" pitchFamily="34" charset="-120"/>
               </a:rPr>
-              <a:t>κ 0.8</a:t>
-            </a:r>
-            <a:endParaRPr lang="en-US" sz="2200" dirty="0"/>
-          </a:p>
-        </p:txBody>
-      </p:sp>
-      <p:sp>
-        <p:nvSpPr>
-          <p:cNvPr id="20" name="Text 18"/>
-          <p:cNvSpPr txBox="1"/>
-          <p:nvPr/>
-        </p:nvSpPr>
-        <p:spPr>
-          <a:xfrm>
-            <a:off x="2770632" y="3602736"/>
-            <a:ext cx="1783080" cy="274320"/>
-          </a:xfrm>
-          <a:prstGeom prst="rect">
-            <a:avLst/>
-          </a:prstGeom>
-          <a:noFill/>
-          <a:ln/>
-        </p:spPr>
-        <p:txBody>
-          <a:bodyPr wrap="square" lIns="0" tIns="0" rIns="0" bIns="0" rtlCol="0" anchor="ctr"/>
-          <a:lstStyle/>
-          <a:p>
-            <a:pPr indent="0" marL="0">
-              <a:buNone/>
-            </a:pPr>
-            <a:r>
-              <a:rPr lang="en-US" sz="1100" dirty="0">
-                <a:solidFill>
-                  <a:schemeClr val="tx2"/>
-                </a:solidFill>
-                <a:latin typeface="Malgun Gothic" pitchFamily="34" charset="0"/>
-                <a:ea typeface="Malgun Gothic" pitchFamily="34" charset="-122"/>
-                <a:cs typeface="Malgun Gothic" pitchFamily="34" charset="-120"/>
-              </a:rPr>
-              <a:t>이중 라벨링 일치도</a:t>
+              <a:t>기록은 폰 안</a:t>
             </a:r>
             <a:endParaRPr lang="en-US" sz="1100" dirty="0"/>
           </a:p>
@@ -6216,42 +6447,25 @@
       </p:sp>
       <p:sp>
         <p:nvSpPr>
-          <p:cNvPr id="21" name="Text 19"/>
-          <p:cNvSpPr txBox="1"/>
-          <p:nvPr/>
-        </p:nvSpPr>
-        <p:spPr>
-          <a:xfrm>
-            <a:off x="457200" y="4114800"/>
-            <a:ext cx="4389120" cy="411480"/>
-          </a:xfrm>
-          <a:prstGeom prst="rect">
-            <a:avLst/>
-          </a:prstGeom>
-          <a:noFill/>
-          <a:ln/>
-        </p:spPr>
-        <p:txBody>
-          <a:bodyPr wrap="square" lIns="0" tIns="0" rIns="0" bIns="0" rtlCol="0" anchor="t"/>
-          <a:lstStyle/>
-          <a:p>
-            <a:pPr indent="0" marL="0">
-              <a:buNone/>
-            </a:pPr>
-            <a:r>
-              <a:rPr lang="en-US" sz="1000" dirty="0">
-                <a:solidFill>
-                  <a:schemeClr val="accent2"/>
-                </a:solidFill>
-                <a:latin typeface="Malgun Gothic" pitchFamily="34" charset="0"/>
-                <a:ea typeface="Malgun Gothic" pitchFamily="34" charset="-122"/>
-                <a:cs typeface="Malgun Gothic" pitchFamily="34" charset="-120"/>
-              </a:rPr>
-              <a:t>수집 현황(10/7): 도박 76 · 정상 70 · 일반 27장 → 7주차 1,000장</a:t>
-            </a:r>
-            <a:endParaRPr lang="en-US" sz="1000" dirty="0"/>
-          </a:p>
-        </p:txBody>
+          <p:cNvPr id="21" name="how card 1"/>
+          <p:cNvSpPr/>
+          <p:nvPr/>
+        </p:nvSpPr>
+        <p:spPr>
+          <a:xfrm>
+            <a:off x="457200" y="2286000"/>
+            <a:ext cx="2606040" cy="1828800"/>
+          </a:xfrm>
+          <a:prstGeom prst="roundRect">
+            <a:avLst>
+              <a:gd name="adj" fmla="val 4000"/>
+            </a:avLst>
+          </a:prstGeom>
+          <a:solidFill>
+            <a:srgbClr val="F3F4F6"/>
+          </a:solidFill>
+          <a:ln/>
+        </p:spPr>
       </p:sp>
       <p:sp>
         <p:nvSpPr>
@@ -6261,31 +6475,8 @@
         </p:nvSpPr>
         <p:spPr>
           <a:xfrm>
-            <a:off x="5230368" y="1143000"/>
-            <a:ext cx="0" cy="3154680"/>
-          </a:xfrm>
-          <a:prstGeom prst="line">
-            <a:avLst/>
-          </a:prstGeom>
-          <a:noFill/>
-          <a:ln w="25400">
-            <a:solidFill>
-              <a:srgbClr val="E3E5E8"/>
-            </a:solidFill>
-            <a:prstDash val="solid"/>
-          </a:ln>
-        </p:spPr>
-      </p:sp>
-      <p:sp>
-        <p:nvSpPr>
-          <p:cNvPr id="23" name="Shape 21"/>
-          <p:cNvSpPr/>
-          <p:nvPr/>
-        </p:nvSpPr>
-        <p:spPr>
-          <a:xfrm>
-            <a:off x="5120640" y="1078992"/>
-            <a:ext cx="219456" cy="219456"/>
+            <a:off x="640080" y="2450592"/>
+            <a:ext cx="384048" cy="384048"/>
           </a:xfrm>
           <a:prstGeom prst="ellipse">
             <a:avLst/>
@@ -6293,24 +6484,43 @@
           <a:solidFill>
             <a:schemeClr val="bg1"/>
           </a:solidFill>
-          <a:ln w="19050">
-            <a:solidFill>
-              <a:srgbClr val="3A3A40"/>
-            </a:solidFill>
-            <a:prstDash val="solid"/>
-          </a:ln>
-        </p:spPr>
-      </p:sp>
-      <p:sp>
-        <p:nvSpPr>
-          <p:cNvPr id="24" name="Text 22"/>
-          <p:cNvSpPr txBox="1"/>
-          <p:nvPr/>
-        </p:nvSpPr>
-        <p:spPr>
-          <a:xfrm>
-            <a:off x="5486400" y="1005840"/>
-            <a:ext cx="594360" cy="365760"/>
+          <a:ln/>
+        </p:spPr>
+      </p:sp>
+      <p:pic>
+        <p:nvPicPr>
+          <p:cNvPr id="23" name="Image 0" descr="preencoded.png">    </p:cNvPr>
+          <p:cNvPicPr>
+            <a:picLocks noChangeAspect="1"/>
+          </p:cNvPicPr>
+          <p:nvPr/>
+        </p:nvPicPr>
+        <p:blipFill>
+          <a:blip r:embed="rId1"/>
+          <a:stretch>
+            <a:fillRect/>
+          </a:stretch>
+        </p:blipFill>
+        <p:spPr>
+          <a:xfrm>
+            <a:off x="740664" y="2551176"/>
+            <a:ext cx="182880" cy="182880"/>
+          </a:xfrm>
+          <a:prstGeom prst="rect">
+            <a:avLst/>
+          </a:prstGeom>
+        </p:spPr>
+      </p:pic>
+      <p:sp>
+        <p:nvSpPr>
+          <p:cNvPr id="24" name="Text 21"/>
+          <p:cNvSpPr txBox="1"/>
+          <p:nvPr/>
+        </p:nvSpPr>
+        <p:spPr>
+          <a:xfrm>
+            <a:off x="1143000" y="2450592"/>
+            <a:ext cx="1783080" cy="384048"/>
           </a:xfrm>
           <a:prstGeom prst="rect">
             <a:avLst/>
@@ -6334,7 +6544,7 @@
                 <a:ea typeface="Malgun Gothic" pitchFamily="34" charset="-122"/>
                 <a:cs typeface="Malgun Gothic" pitchFamily="34" charset="-120"/>
               </a:rPr>
-              <a:t>7주</a:t>
+              <a:t>무엇을 가르치나</a:t>
             </a:r>
             <a:endParaRPr lang="en-US" sz="1300" dirty="0"/>
           </a:p>
@@ -6342,30 +6552,30 @@
       </p:sp>
       <p:sp>
         <p:nvSpPr>
-          <p:cNvPr id="25" name="Text 23"/>
-          <p:cNvSpPr txBox="1"/>
-          <p:nvPr/>
-        </p:nvSpPr>
-        <p:spPr>
-          <a:xfrm>
-            <a:off x="6080760" y="1005840"/>
-            <a:ext cx="2606040" cy="365760"/>
-          </a:xfrm>
-          <a:prstGeom prst="rect">
-            <a:avLst/>
-          </a:prstGeom>
-          <a:noFill/>
-          <a:ln/>
-        </p:spPr>
-        <p:txBody>
-          <a:bodyPr wrap="square" lIns="0" tIns="0" rIns="0" bIns="0" rtlCol="0" anchor="ctr"/>
-          <a:lstStyle/>
-          <a:p>
-            <a:pPr indent="0" marL="0">
-              <a:buNone/>
-            </a:pPr>
-            <a:r>
-              <a:rPr lang="en-US" sz="1200" dirty="0">
+          <p:cNvPr id="25" name="Text 22"/>
+          <p:cNvSpPr txBox="1"/>
+          <p:nvPr/>
+        </p:nvSpPr>
+        <p:spPr>
+          <a:xfrm>
+            <a:off x="640080" y="2926080"/>
+            <a:ext cx="2240280" cy="1097280"/>
+          </a:xfrm>
+          <a:prstGeom prst="rect">
+            <a:avLst/>
+          </a:prstGeom>
+          <a:noFill/>
+          <a:ln/>
+        </p:spPr>
+        <p:txBody>
+          <a:bodyPr wrap="square" lIns="0" tIns="0" rIns="0" bIns="0" rtlCol="0" anchor="t"/>
+          <a:lstStyle/>
+          <a:p>
+            <a:pPr indent="0" marL="0">
+              <a:buNone/>
+            </a:pPr>
+            <a:r>
+              <a:rPr lang="en-US" sz="1100" dirty="0">
                 <a:solidFill>
                   <a:schemeClr val="tx2"/>
                 </a:solidFill>
@@ -6373,22 +6583,44 @@
                 <a:ea typeface="Malgun Gothic" pitchFamily="34" charset="-122"/>
                 <a:cs typeface="Malgun Gothic" pitchFamily="34" charset="-120"/>
               </a:rPr>
-              <a:t>상담사·회복자 인터뷰 · 라벨링 기준서</a:t>
-            </a:r>
-            <a:endParaRPr lang="en-US" sz="1200" dirty="0"/>
-          </a:p>
-        </p:txBody>
-      </p:sp>
-      <p:sp>
-        <p:nvSpPr>
-          <p:cNvPr id="26" name="Shape 24"/>
+              <a:t>도박 화면 / 충전 화면 / 정상 게임·결제 / 일반 — 한국어 모바일 화면 2,000~3,000장. 정상 게임을 도박으로 잘못 잡지 않도록 '헷갈리는 정상 화면'을 일부러 많이 넣는다.</a:t>
+            </a:r>
+            <a:endParaRPr lang="en-US" sz="1100" dirty="0"/>
+          </a:p>
+        </p:txBody>
+      </p:sp>
+      <p:sp>
+        <p:nvSpPr>
+          <p:cNvPr id="26" name="how card 2"/>
           <p:cNvSpPr/>
           <p:nvPr/>
         </p:nvSpPr>
         <p:spPr>
           <a:xfrm>
-            <a:off x="5120640" y="1764792"/>
-            <a:ext cx="219456" cy="219456"/>
+            <a:off x="3268980" y="2286000"/>
+            <a:ext cx="2606040" cy="1828800"/>
+          </a:xfrm>
+          <a:prstGeom prst="roundRect">
+            <a:avLst>
+              <a:gd name="adj" fmla="val 4000"/>
+            </a:avLst>
+          </a:prstGeom>
+          <a:solidFill>
+            <a:srgbClr val="F3F4F6"/>
+          </a:solidFill>
+          <a:ln/>
+        </p:spPr>
+      </p:sp>
+      <p:sp>
+        <p:nvSpPr>
+          <p:cNvPr id="27" name="Shape 24"/>
+          <p:cNvSpPr/>
+          <p:nvPr/>
+        </p:nvSpPr>
+        <p:spPr>
+          <a:xfrm>
+            <a:off x="3451860" y="2450592"/>
+            <a:ext cx="384048" cy="384048"/>
           </a:xfrm>
           <a:prstGeom prst="ellipse">
             <a:avLst/>
@@ -6396,24 +6628,43 @@
           <a:solidFill>
             <a:schemeClr val="bg1"/>
           </a:solidFill>
-          <a:ln w="19050">
-            <a:solidFill>
-              <a:srgbClr val="3A3A40"/>
-            </a:solidFill>
-            <a:prstDash val="solid"/>
-          </a:ln>
-        </p:spPr>
-      </p:sp>
-      <p:sp>
-        <p:nvSpPr>
-          <p:cNvPr id="27" name="Text 25"/>
-          <p:cNvSpPr txBox="1"/>
-          <p:nvPr/>
-        </p:nvSpPr>
-        <p:spPr>
-          <a:xfrm>
-            <a:off x="5486400" y="1691640"/>
-            <a:ext cx="594360" cy="365760"/>
+          <a:ln/>
+        </p:spPr>
+      </p:sp>
+      <p:pic>
+        <p:nvPicPr>
+          <p:cNvPr id="28" name="Image 1" descr="preencoded.png">    </p:cNvPr>
+          <p:cNvPicPr>
+            <a:picLocks noChangeAspect="1"/>
+          </p:cNvPicPr>
+          <p:nvPr/>
+        </p:nvPicPr>
+        <p:blipFill>
+          <a:blip r:embed="rId2"/>
+          <a:stretch>
+            <a:fillRect/>
+          </a:stretch>
+        </p:blipFill>
+        <p:spPr>
+          <a:xfrm>
+            <a:off x="3552444" y="2551176"/>
+            <a:ext cx="182880" cy="182880"/>
+          </a:xfrm>
+          <a:prstGeom prst="rect">
+            <a:avLst/>
+          </a:prstGeom>
+        </p:spPr>
+      </p:pic>
+      <p:sp>
+        <p:nvSpPr>
+          <p:cNvPr id="29" name="Text 25"/>
+          <p:cNvSpPr txBox="1"/>
+          <p:nvPr/>
+        </p:nvSpPr>
+        <p:spPr>
+          <a:xfrm>
+            <a:off x="3954780" y="2450592"/>
+            <a:ext cx="1783080" cy="384048"/>
           </a:xfrm>
           <a:prstGeom prst="rect">
             <a:avLst/>
@@ -6437,7 +6688,7 @@
                 <a:ea typeface="Malgun Gothic" pitchFamily="34" charset="-122"/>
                 <a:cs typeface="Malgun Gothic" pitchFamily="34" charset="-120"/>
               </a:rPr>
-              <a:t>8주</a:t>
+              <a:t>어떻게 판정하나</a:t>
             </a:r>
             <a:endParaRPr lang="en-US" sz="1300" dirty="0"/>
           </a:p>
@@ -6445,30 +6696,30 @@
       </p:sp>
       <p:sp>
         <p:nvSpPr>
-          <p:cNvPr id="28" name="Text 26"/>
-          <p:cNvSpPr txBox="1"/>
-          <p:nvPr/>
-        </p:nvSpPr>
-        <p:spPr>
-          <a:xfrm>
-            <a:off x="6080760" y="1691640"/>
-            <a:ext cx="2606040" cy="365760"/>
-          </a:xfrm>
-          <a:prstGeom prst="rect">
-            <a:avLst/>
-          </a:prstGeom>
-          <a:noFill/>
-          <a:ln/>
-        </p:spPr>
-        <p:txBody>
-          <a:bodyPr wrap="square" lIns="0" tIns="0" rIns="0" bIns="0" rtlCol="0" anchor="ctr"/>
-          <a:lstStyle/>
-          <a:p>
-            <a:pPr indent="0" marL="0">
-              <a:buNone/>
-            </a:pPr>
-            <a:r>
-              <a:rPr lang="en-US" sz="1200" dirty="0">
+          <p:cNvPr id="30" name="Text 26"/>
+          <p:cNvSpPr txBox="1"/>
+          <p:nvPr/>
+        </p:nvSpPr>
+        <p:spPr>
+          <a:xfrm>
+            <a:off x="3451860" y="2926080"/>
+            <a:ext cx="2240280" cy="1097280"/>
+          </a:xfrm>
+          <a:prstGeom prst="rect">
+            <a:avLst/>
+          </a:prstGeom>
+          <a:noFill/>
+          <a:ln/>
+        </p:spPr>
+        <p:txBody>
+          <a:bodyPr wrap="square" lIns="0" tIns="0" rIns="0" bIns="0" rtlCol="0" anchor="t"/>
+          <a:lstStyle/>
+          <a:p>
+            <a:pPr indent="0" marL="0">
+              <a:buNone/>
+            </a:pPr>
+            <a:r>
+              <a:rPr lang="en-US" sz="1100" dirty="0">
                 <a:solidFill>
                   <a:schemeClr val="tx2"/>
                 </a:solidFill>
@@ -6476,125 +6727,44 @@
                 <a:ea typeface="Malgun Gothic" pitchFamily="34" charset="-122"/>
                 <a:cs typeface="Malgun Gothic" pitchFamily="34" charset="-120"/>
               </a:rPr>
-              <a:t>종이 프로토타입 · 15/30/60초 비교</a:t>
-            </a:r>
-            <a:endParaRPr lang="en-US" sz="1200" dirty="0"/>
-          </a:p>
-        </p:txBody>
-      </p:sp>
-      <p:sp>
-        <p:nvSpPr>
-          <p:cNvPr id="29" name="Shape 27"/>
+              <a:t>글자를 읽는 눈과 생김새를 보는 눈을 합친다. 둘 중 하나만 쓸 때보다 정말 나은지, 같은 시험지로 비교해 확인한다.</a:t>
+            </a:r>
+            <a:endParaRPr lang="en-US" sz="1100" dirty="0"/>
+          </a:p>
+        </p:txBody>
+      </p:sp>
+      <p:sp>
+        <p:nvSpPr>
+          <p:cNvPr id="31" name="how card 3"/>
           <p:cNvSpPr/>
           <p:nvPr/>
         </p:nvSpPr>
         <p:spPr>
           <a:xfrm>
-            <a:off x="5120640" y="2450592"/>
-            <a:ext cx="219456" cy="219456"/>
-          </a:xfrm>
-          <a:prstGeom prst="ellipse">
-            <a:avLst/>
+            <a:off x="6080760" y="2286000"/>
+            <a:ext cx="2606040" cy="1828800"/>
+          </a:xfrm>
+          <a:prstGeom prst="roundRect">
+            <a:avLst>
+              <a:gd name="adj" fmla="val 4000"/>
+            </a:avLst>
           </a:prstGeom>
           <a:solidFill>
-            <a:schemeClr val="accent1"/>
+            <a:srgbClr val="F3F4F6"/>
           </a:solidFill>
-          <a:ln w="19050">
-            <a:solidFill>
-              <a:srgbClr val="3A3A40"/>
-            </a:solidFill>
-            <a:prstDash val="solid"/>
-          </a:ln>
-        </p:spPr>
-      </p:sp>
-      <p:sp>
-        <p:nvSpPr>
-          <p:cNvPr id="30" name="Text 28"/>
-          <p:cNvSpPr txBox="1"/>
-          <p:nvPr/>
-        </p:nvSpPr>
-        <p:spPr>
-          <a:xfrm>
-            <a:off x="5486400" y="2377440"/>
-            <a:ext cx="594360" cy="365760"/>
-          </a:xfrm>
-          <a:prstGeom prst="rect">
-            <a:avLst/>
-          </a:prstGeom>
-          <a:noFill/>
-          <a:ln/>
-        </p:spPr>
-        <p:txBody>
-          <a:bodyPr wrap="square" lIns="0" tIns="0" rIns="0" bIns="0" rtlCol="0" anchor="ctr"/>
-          <a:lstStyle/>
-          <a:p>
-            <a:pPr indent="0" marL="0">
-              <a:buNone/>
-            </a:pPr>
-            <a:r>
-              <a:rPr lang="en-US" sz="1300" b="1" dirty="0">
-                <a:solidFill>
-                  <a:schemeClr val="tx1"/>
-                </a:solidFill>
-                <a:latin typeface="Malgun Gothic" pitchFamily="34" charset="0"/>
-                <a:ea typeface="Malgun Gothic" pitchFamily="34" charset="-122"/>
-                <a:cs typeface="Malgun Gothic" pitchFamily="34" charset="-120"/>
-              </a:rPr>
-              <a:t>11주</a:t>
-            </a:r>
-            <a:endParaRPr lang="en-US" sz="1300" dirty="0"/>
-          </a:p>
-        </p:txBody>
-      </p:sp>
-      <p:sp>
-        <p:nvSpPr>
-          <p:cNvPr id="31" name="Text 29"/>
-          <p:cNvSpPr txBox="1"/>
-          <p:nvPr/>
-        </p:nvSpPr>
-        <p:spPr>
-          <a:xfrm>
-            <a:off x="6080760" y="2377440"/>
-            <a:ext cx="2606040" cy="365760"/>
-          </a:xfrm>
-          <a:prstGeom prst="rect">
-            <a:avLst/>
-          </a:prstGeom>
-          <a:noFill/>
-          <a:ln/>
-        </p:spPr>
-        <p:txBody>
-          <a:bodyPr wrap="square" lIns="0" tIns="0" rIns="0" bIns="0" rtlCol="0" anchor="ctr"/>
-          <a:lstStyle/>
-          <a:p>
-            <a:pPr indent="0" marL="0">
-              <a:buNone/>
-            </a:pPr>
-            <a:r>
-              <a:rPr lang="en-US" sz="1200" dirty="0">
-                <a:solidFill>
-                  <a:schemeClr val="tx2"/>
-                </a:solidFill>
-                <a:latin typeface="Malgun Gothic" pitchFamily="34" charset="0"/>
-                <a:ea typeface="Malgun Gothic" pitchFamily="34" charset="-122"/>
-                <a:cs typeface="Malgun Gothic" pitchFamily="34" charset="-120"/>
-              </a:rPr>
-              <a:t>중간발표 · 안드로이드 데모 시연</a:t>
-            </a:r>
-            <a:endParaRPr lang="en-US" sz="1200" dirty="0"/>
-          </a:p>
-        </p:txBody>
-      </p:sp>
-      <p:sp>
-        <p:nvSpPr>
-          <p:cNvPr id="32" name="Shape 30"/>
+          <a:ln/>
+        </p:spPr>
+      </p:sp>
+      <p:sp>
+        <p:nvSpPr>
+          <p:cNvPr id="32" name="Shape 28"/>
           <p:cNvSpPr/>
           <p:nvPr/>
         </p:nvSpPr>
         <p:spPr>
           <a:xfrm>
-            <a:off x="5120640" y="3136392"/>
-            <a:ext cx="219456" cy="219456"/>
+            <a:off x="6263640" y="2450592"/>
+            <a:ext cx="384048" cy="384048"/>
           </a:xfrm>
           <a:prstGeom prst="ellipse">
             <a:avLst/>
@@ -6602,24 +6772,43 @@
           <a:solidFill>
             <a:schemeClr val="bg1"/>
           </a:solidFill>
-          <a:ln w="19050">
-            <a:solidFill>
-              <a:srgbClr val="3A3A40"/>
-            </a:solidFill>
-            <a:prstDash val="solid"/>
-          </a:ln>
-        </p:spPr>
-      </p:sp>
-      <p:sp>
-        <p:nvSpPr>
-          <p:cNvPr id="33" name="Text 31"/>
-          <p:cNvSpPr txBox="1"/>
-          <p:nvPr/>
-        </p:nvSpPr>
-        <p:spPr>
-          <a:xfrm>
-            <a:off x="5486400" y="3063240"/>
-            <a:ext cx="594360" cy="365760"/>
+          <a:ln/>
+        </p:spPr>
+      </p:sp>
+      <p:pic>
+        <p:nvPicPr>
+          <p:cNvPr id="33" name="Image 2" descr="preencoded.png">    </p:cNvPr>
+          <p:cNvPicPr>
+            <a:picLocks noChangeAspect="1"/>
+          </p:cNvPicPr>
+          <p:nvPr/>
+        </p:nvPicPr>
+        <p:blipFill>
+          <a:blip r:embed="rId3"/>
+          <a:stretch>
+            <a:fillRect/>
+          </a:stretch>
+        </p:blipFill>
+        <p:spPr>
+          <a:xfrm>
+            <a:off x="6364224" y="2551176"/>
+            <a:ext cx="182880" cy="182880"/>
+          </a:xfrm>
+          <a:prstGeom prst="rect">
+            <a:avLst/>
+          </a:prstGeom>
+        </p:spPr>
+      </p:pic>
+      <p:sp>
+        <p:nvSpPr>
+          <p:cNvPr id="34" name="Text 29"/>
+          <p:cNvSpPr txBox="1"/>
+          <p:nvPr/>
+        </p:nvSpPr>
+        <p:spPr>
+          <a:xfrm>
+            <a:off x="6766560" y="2450592"/>
+            <a:ext cx="1783080" cy="384048"/>
           </a:xfrm>
           <a:prstGeom prst="rect">
             <a:avLst/>
@@ -6643,7 +6832,7 @@
                 <a:ea typeface="Malgun Gothic" pitchFamily="34" charset="-122"/>
                 <a:cs typeface="Malgun Gothic" pitchFamily="34" charset="-120"/>
               </a:rPr>
-              <a:t>13주</a:t>
+              <a:t>어디서 돌아가나</a:t>
             </a:r>
             <a:endParaRPr lang="en-US" sz="1300" dirty="0"/>
           </a:p>
@@ -6651,14 +6840,53 @@
       </p:sp>
       <p:sp>
         <p:nvSpPr>
-          <p:cNvPr id="34" name="Text 32"/>
-          <p:cNvSpPr txBox="1"/>
-          <p:nvPr/>
-        </p:nvSpPr>
-        <p:spPr>
-          <a:xfrm>
-            <a:off x="6080760" y="3063240"/>
-            <a:ext cx="2606040" cy="365760"/>
+          <p:cNvPr id="35" name="Text 30"/>
+          <p:cNvSpPr txBox="1"/>
+          <p:nvPr/>
+        </p:nvSpPr>
+        <p:spPr>
+          <a:xfrm>
+            <a:off x="6263640" y="2926080"/>
+            <a:ext cx="2240280" cy="1097280"/>
+          </a:xfrm>
+          <a:prstGeom prst="rect">
+            <a:avLst/>
+          </a:prstGeom>
+          <a:noFill/>
+          <a:ln/>
+        </p:spPr>
+        <p:txBody>
+          <a:bodyPr wrap="square" lIns="0" tIns="0" rIns="0" bIns="0" rtlCol="0" anchor="t"/>
+          <a:lstStyle/>
+          <a:p>
+            <a:pPr indent="0" marL="0">
+              <a:buNone/>
+            </a:pPr>
+            <a:r>
+              <a:rPr lang="en-US" sz="1100" dirty="0">
+                <a:solidFill>
+                  <a:schemeClr val="tx2"/>
+                </a:solidFill>
+                <a:latin typeface="Malgun Gothic" pitchFamily="34" charset="0"/>
+                <a:ea typeface="Malgun Gothic" pitchFamily="34" charset="-122"/>
+                <a:cs typeface="Malgun Gothic" pitchFamily="34" charset="-120"/>
+              </a:rPr>
+              <a:t>폰 안에서 1장당 1초, 50MB. 화면도 기록도 서버로 보내지 않는다. 1차는 안드로이드, iOS는 후속.</a:t>
+            </a:r>
+            <a:endParaRPr lang="en-US" sz="1100" dirty="0"/>
+          </a:p>
+        </p:txBody>
+      </p:sp>
+      <p:sp>
+        <p:nvSpPr>
+          <p:cNvPr id="36" name="tech footnote"/>
+          <p:cNvSpPr txBox="1"/>
+          <p:nvPr/>
+        </p:nvSpPr>
+        <p:spPr>
+          <a:xfrm>
+            <a:off x="457200" y="4251960"/>
+            <a:ext cx="8229600" cy="274320"/>
           </a:xfrm>
           <a:prstGeom prst="rect">
             <a:avLst/>
@@ -6674,120 +6902,17 @@
               <a:buNone/>
             </a:pPr>
             <a:r>
-              <a:rPr lang="en-US" sz="1200" dirty="0">
-                <a:solidFill>
-                  <a:schemeClr val="tx2"/>
-                </a:solidFill>
-                <a:latin typeface="Malgun Gothic" pitchFamily="34" charset="0"/>
-                <a:ea typeface="Malgun Gothic" pitchFamily="34" charset="-122"/>
-                <a:cs typeface="Malgun Gothic" pitchFamily="34" charset="-120"/>
-              </a:rPr>
-              <a:t>2차 테스트 · 장부·신뢰인·1336</a:t>
-            </a:r>
-            <a:endParaRPr lang="en-US" sz="1200" dirty="0"/>
-          </a:p>
-        </p:txBody>
-      </p:sp>
-      <p:sp>
-        <p:nvSpPr>
-          <p:cNvPr id="35" name="Shape 33"/>
-          <p:cNvSpPr/>
-          <p:nvPr/>
-        </p:nvSpPr>
-        <p:spPr>
-          <a:xfrm>
-            <a:off x="5120640" y="3822192"/>
-            <a:ext cx="219456" cy="219456"/>
-          </a:xfrm>
-          <a:prstGeom prst="ellipse">
-            <a:avLst/>
-          </a:prstGeom>
-          <a:solidFill>
-            <a:schemeClr val="bg1"/>
-          </a:solidFill>
-          <a:ln w="19050">
-            <a:solidFill>
-              <a:srgbClr val="3A3A40"/>
-            </a:solidFill>
-            <a:prstDash val="solid"/>
-          </a:ln>
-        </p:spPr>
-      </p:sp>
-      <p:sp>
-        <p:nvSpPr>
-          <p:cNvPr id="36" name="Text 34"/>
-          <p:cNvSpPr txBox="1"/>
-          <p:nvPr/>
-        </p:nvSpPr>
-        <p:spPr>
-          <a:xfrm>
-            <a:off x="5486400" y="3749040"/>
-            <a:ext cx="594360" cy="365760"/>
-          </a:xfrm>
-          <a:prstGeom prst="rect">
-            <a:avLst/>
-          </a:prstGeom>
-          <a:noFill/>
-          <a:ln/>
-        </p:spPr>
-        <p:txBody>
-          <a:bodyPr wrap="square" lIns="0" tIns="0" rIns="0" bIns="0" rtlCol="0" anchor="ctr"/>
-          <a:lstStyle/>
-          <a:p>
-            <a:pPr indent="0" marL="0">
-              <a:buNone/>
-            </a:pPr>
-            <a:r>
-              <a:rPr lang="en-US" sz="1300" b="1" dirty="0">
-                <a:solidFill>
-                  <a:schemeClr val="tx1"/>
-                </a:solidFill>
-                <a:latin typeface="Malgun Gothic" pitchFamily="34" charset="0"/>
-                <a:ea typeface="Malgun Gothic" pitchFamily="34" charset="-122"/>
-                <a:cs typeface="Malgun Gothic" pitchFamily="34" charset="-120"/>
-              </a:rPr>
-              <a:t>15주</a:t>
-            </a:r>
-            <a:endParaRPr lang="en-US" sz="1300" dirty="0"/>
-          </a:p>
-        </p:txBody>
-      </p:sp>
-      <p:sp>
-        <p:nvSpPr>
-          <p:cNvPr id="37" name="Text 35"/>
-          <p:cNvSpPr txBox="1"/>
-          <p:nvPr/>
-        </p:nvSpPr>
-        <p:spPr>
-          <a:xfrm>
-            <a:off x="6080760" y="3749040"/>
-            <a:ext cx="2606040" cy="365760"/>
-          </a:xfrm>
-          <a:prstGeom prst="rect">
-            <a:avLst/>
-          </a:prstGeom>
-          <a:noFill/>
-          <a:ln/>
-        </p:spPr>
-        <p:txBody>
-          <a:bodyPr wrap="square" lIns="0" tIns="0" rIns="0" bIns="0" rtlCol="0" anchor="ctr"/>
-          <a:lstStyle/>
-          <a:p>
-            <a:pPr indent="0" marL="0">
-              <a:buNone/>
-            </a:pPr>
-            <a:r>
-              <a:rPr lang="en-US" sz="1200" dirty="0">
-                <a:solidFill>
-                  <a:schemeClr val="tx2"/>
-                </a:solidFill>
-                <a:latin typeface="Malgun Gothic" pitchFamily="34" charset="0"/>
-                <a:ea typeface="Malgun Gothic" pitchFamily="34" charset="-122"/>
-                <a:cs typeface="Malgun Gothic" pitchFamily="34" charset="-120"/>
-              </a:rPr>
-              <a:t>최종 · 모델 비교 결과 · 데모 영상</a:t>
-            </a:r>
-            <a:endParaRPr lang="en-US" sz="1200" dirty="0"/>
+              <a:rPr lang="en-US" sz="950" dirty="0">
+                <a:solidFill>
+                  <a:schemeClr val="accent2"/>
+                </a:solidFill>
+                <a:latin typeface="Malgun Gothic" pitchFamily="34" charset="0"/>
+                <a:ea typeface="Malgun Gothic" pitchFamily="34" charset="-122"/>
+                <a:cs typeface="Malgun Gothic" pitchFamily="34" charset="-120"/>
+              </a:rPr>
+              <a:t>기술 구성(계획서 §3.5): PaddleOCR(글자) · KLUE-RoBERTa(텍스트) · ViT(이미지) · late fusion · TFLite(온디바이스)</a:t>
+            </a:r>
+            <a:endParaRPr lang="en-US" sz="950" dirty="0"/>
           </a:p>
         </p:txBody>
       </p:sp>
@@ -6863,6 +6988,1291 @@
       </p:grpSpPr>
       <p:sp>
         <p:nvSpPr>
+          <p:cNvPr id="2" name="Text 1"/>
+          <p:cNvSpPr/>
+          <p:nvPr>
+            <p:ph idx="101" type="title" hasCustomPrompt="1"/>
+          </p:nvPr>
+        </p:nvSpPr>
+        <p:spPr>
+          <a:xfrm>
+            <a:off x="457200" y="274320"/>
+            <a:ext cx="8229600" cy="548640"/>
+          </a:xfrm>
+          <a:prstGeom prst="rect">
+            <a:avLst/>
+          </a:prstGeom>
+          <a:noFill/>
+          <a:ln/>
+        </p:spPr>
+        <p:txBody>
+          <a:bodyPr wrap="square" lIns="0" tIns="0" rIns="0" bIns="0" rtlCol="0" anchor="ctr"/>
+          <a:lstStyle/>
+          <a:p>
+            <a:pPr indent="0" marL="0">
+              <a:buNone/>
+            </a:pPr>
+            <a:r>
+              <a:rPr lang="en-US" sz="2400" b="1" dirty="0">
+                <a:solidFill>
+                  <a:schemeClr val="tx1"/>
+                </a:solidFill>
+              </a:rPr>
+              <a:t>무엇으로 성공을 재나 · 앞으로의 일정</a:t>
+            </a:r>
+            <a:endParaRPr lang="en-US" sz="2400" dirty="0"/>
+          </a:p>
+        </p:txBody>
+      </p:sp>
+      <p:sp>
+        <p:nvSpPr>
+          <p:cNvPr id="3" name="kpi 1"/>
+          <p:cNvSpPr/>
+          <p:nvPr/>
+        </p:nvSpPr>
+        <p:spPr>
+          <a:xfrm>
+            <a:off x="457200" y="1005840"/>
+            <a:ext cx="2011680" cy="896112"/>
+          </a:xfrm>
+          <a:prstGeom prst="roundRect">
+            <a:avLst>
+              <a:gd name="adj" fmla="val 8163"/>
+            </a:avLst>
+          </a:prstGeom>
+          <a:solidFill>
+            <a:srgbClr val="F3F4F6"/>
+          </a:solidFill>
+          <a:ln/>
+        </p:spPr>
+      </p:sp>
+      <p:sp>
+        <p:nvSpPr>
+          <p:cNvPr id="4" name="Text 2"/>
+          <p:cNvSpPr txBox="1"/>
+          <p:nvPr/>
+        </p:nvSpPr>
+        <p:spPr>
+          <a:xfrm>
+            <a:off x="621792" y="1078992"/>
+            <a:ext cx="1737360" cy="384048"/>
+          </a:xfrm>
+          <a:prstGeom prst="rect">
+            <a:avLst/>
+          </a:prstGeom>
+          <a:noFill/>
+          <a:ln/>
+        </p:spPr>
+        <p:txBody>
+          <a:bodyPr wrap="square" lIns="0" tIns="0" rIns="0" bIns="0" rtlCol="0" anchor="ctr"/>
+          <a:lstStyle/>
+          <a:p>
+            <a:pPr indent="0" marL="0">
+              <a:buNone/>
+            </a:pPr>
+            <a:r>
+              <a:rPr lang="en-US" sz="2000" b="1" dirty="0">
+                <a:solidFill>
+                  <a:schemeClr val="tx1"/>
+                </a:solidFill>
+                <a:latin typeface="Malgun Gothic" pitchFamily="34" charset="0"/>
+                <a:ea typeface="Malgun Gothic" pitchFamily="34" charset="-122"/>
+                <a:cs typeface="Malgun Gothic" pitchFamily="34" charset="-120"/>
+              </a:rPr>
+              <a:t>0.90</a:t>
+            </a:r>
+            <a:endParaRPr lang="en-US" sz="2000" dirty="0"/>
+          </a:p>
+        </p:txBody>
+      </p:sp>
+      <p:sp>
+        <p:nvSpPr>
+          <p:cNvPr id="5" name="Text 3"/>
+          <p:cNvSpPr txBox="1"/>
+          <p:nvPr/>
+        </p:nvSpPr>
+        <p:spPr>
+          <a:xfrm>
+            <a:off x="621792" y="1463040"/>
+            <a:ext cx="1783080" cy="411480"/>
+          </a:xfrm>
+          <a:prstGeom prst="rect">
+            <a:avLst/>
+          </a:prstGeom>
+          <a:noFill/>
+          <a:ln/>
+        </p:spPr>
+        <p:txBody>
+          <a:bodyPr wrap="square" lIns="0" tIns="0" rIns="0" bIns="0" rtlCol="0" anchor="t"/>
+          <a:lstStyle/>
+          <a:p>
+            <a:pPr indent="0" marL="0">
+              <a:buNone/>
+            </a:pPr>
+            <a:r>
+              <a:rPr lang="en-US" sz="1050" dirty="0">
+                <a:solidFill>
+                  <a:schemeClr val="tx2"/>
+                </a:solidFill>
+                <a:latin typeface="Malgun Gothic" pitchFamily="34" charset="0"/>
+                <a:ea typeface="Malgun Gothic" pitchFamily="34" charset="-122"/>
+                <a:cs typeface="Malgun Gothic" pitchFamily="34" charset="-120"/>
+              </a:rPr>
+              <a:t>도박 화면을 맞히는 정확도 (F1)</a:t>
+            </a:r>
+            <a:endParaRPr lang="en-US" sz="1050" dirty="0"/>
+          </a:p>
+        </p:txBody>
+      </p:sp>
+      <p:sp>
+        <p:nvSpPr>
+          <p:cNvPr id="6" name="kpi 2"/>
+          <p:cNvSpPr/>
+          <p:nvPr/>
+        </p:nvSpPr>
+        <p:spPr>
+          <a:xfrm>
+            <a:off x="2606040" y="1005840"/>
+            <a:ext cx="2011680" cy="896112"/>
+          </a:xfrm>
+          <a:prstGeom prst="roundRect">
+            <a:avLst>
+              <a:gd name="adj" fmla="val 8163"/>
+            </a:avLst>
+          </a:prstGeom>
+          <a:solidFill>
+            <a:srgbClr val="F3F4F6"/>
+          </a:solidFill>
+          <a:ln/>
+        </p:spPr>
+      </p:sp>
+      <p:sp>
+        <p:nvSpPr>
+          <p:cNvPr id="7" name="Text 5"/>
+          <p:cNvSpPr txBox="1"/>
+          <p:nvPr/>
+        </p:nvSpPr>
+        <p:spPr>
+          <a:xfrm>
+            <a:off x="2770632" y="1078992"/>
+            <a:ext cx="1737360" cy="384048"/>
+          </a:xfrm>
+          <a:prstGeom prst="rect">
+            <a:avLst/>
+          </a:prstGeom>
+          <a:noFill/>
+          <a:ln/>
+        </p:spPr>
+        <p:txBody>
+          <a:bodyPr wrap="square" lIns="0" tIns="0" rIns="0" bIns="0" rtlCol="0" anchor="ctr"/>
+          <a:lstStyle/>
+          <a:p>
+            <a:pPr indent="0" marL="0">
+              <a:buNone/>
+            </a:pPr>
+            <a:r>
+              <a:rPr lang="en-US" sz="2000" b="1" dirty="0">
+                <a:solidFill>
+                  <a:schemeClr val="tx1"/>
+                </a:solidFill>
+                <a:latin typeface="Malgun Gothic" pitchFamily="34" charset="0"/>
+                <a:ea typeface="Malgun Gothic" pitchFamily="34" charset="-122"/>
+                <a:cs typeface="Malgun Gothic" pitchFamily="34" charset="-120"/>
+              </a:rPr>
+              <a:t>≤ 2%</a:t>
+            </a:r>
+            <a:endParaRPr lang="en-US" sz="2000" dirty="0"/>
+          </a:p>
+        </p:txBody>
+      </p:sp>
+      <p:sp>
+        <p:nvSpPr>
+          <p:cNvPr id="8" name="Text 6"/>
+          <p:cNvSpPr txBox="1"/>
+          <p:nvPr/>
+        </p:nvSpPr>
+        <p:spPr>
+          <a:xfrm>
+            <a:off x="2770632" y="1463040"/>
+            <a:ext cx="1783080" cy="411480"/>
+          </a:xfrm>
+          <a:prstGeom prst="rect">
+            <a:avLst/>
+          </a:prstGeom>
+          <a:noFill/>
+          <a:ln/>
+        </p:spPr>
+        <p:txBody>
+          <a:bodyPr wrap="square" lIns="0" tIns="0" rIns="0" bIns="0" rtlCol="0" anchor="t"/>
+          <a:lstStyle/>
+          <a:p>
+            <a:pPr indent="0" marL="0">
+              <a:buNone/>
+            </a:pPr>
+            <a:r>
+              <a:rPr lang="en-US" sz="1050" dirty="0">
+                <a:solidFill>
+                  <a:schemeClr val="tx2"/>
+                </a:solidFill>
+                <a:latin typeface="Malgun Gothic" pitchFamily="34" charset="0"/>
+                <a:ea typeface="Malgun Gothic" pitchFamily="34" charset="-122"/>
+                <a:cs typeface="Malgun Gothic" pitchFamily="34" charset="-120"/>
+              </a:rPr>
+              <a:t>정상 게임·결제를 도박으로 잘못 잡는 비율</a:t>
+            </a:r>
+            <a:endParaRPr lang="en-US" sz="1050" dirty="0"/>
+          </a:p>
+        </p:txBody>
+      </p:sp>
+      <p:sp>
+        <p:nvSpPr>
+          <p:cNvPr id="9" name="kpi 3"/>
+          <p:cNvSpPr/>
+          <p:nvPr/>
+        </p:nvSpPr>
+        <p:spPr>
+          <a:xfrm>
+            <a:off x="457200" y="2029968"/>
+            <a:ext cx="2011680" cy="896112"/>
+          </a:xfrm>
+          <a:prstGeom prst="roundRect">
+            <a:avLst>
+              <a:gd name="adj" fmla="val 8163"/>
+            </a:avLst>
+          </a:prstGeom>
+          <a:solidFill>
+            <a:srgbClr val="F3F4F6"/>
+          </a:solidFill>
+          <a:ln/>
+        </p:spPr>
+      </p:sp>
+      <p:sp>
+        <p:nvSpPr>
+          <p:cNvPr id="10" name="Text 8"/>
+          <p:cNvSpPr txBox="1"/>
+          <p:nvPr/>
+        </p:nvSpPr>
+        <p:spPr>
+          <a:xfrm>
+            <a:off x="621792" y="2103120"/>
+            <a:ext cx="1737360" cy="384048"/>
+          </a:xfrm>
+          <a:prstGeom prst="rect">
+            <a:avLst/>
+          </a:prstGeom>
+          <a:noFill/>
+          <a:ln/>
+        </p:spPr>
+        <p:txBody>
+          <a:bodyPr wrap="square" lIns="0" tIns="0" rIns="0" bIns="0" rtlCol="0" anchor="ctr"/>
+          <a:lstStyle/>
+          <a:p>
+            <a:pPr indent="0" marL="0">
+              <a:buNone/>
+            </a:pPr>
+            <a:r>
+              <a:rPr lang="en-US" sz="2000" b="1" dirty="0">
+                <a:solidFill>
+                  <a:schemeClr val="tx1"/>
+                </a:solidFill>
+                <a:latin typeface="Malgun Gothic" pitchFamily="34" charset="0"/>
+                <a:ea typeface="Malgun Gothic" pitchFamily="34" charset="-122"/>
+                <a:cs typeface="Malgun Gothic" pitchFamily="34" charset="-120"/>
+              </a:rPr>
+              <a:t>0.90</a:t>
+            </a:r>
+            <a:endParaRPr lang="en-US" sz="2000" dirty="0"/>
+          </a:p>
+        </p:txBody>
+      </p:sp>
+      <p:sp>
+        <p:nvSpPr>
+          <p:cNvPr id="11" name="Text 9"/>
+          <p:cNvSpPr txBox="1"/>
+          <p:nvPr/>
+        </p:nvSpPr>
+        <p:spPr>
+          <a:xfrm>
+            <a:off x="621792" y="2487168"/>
+            <a:ext cx="1783080" cy="411480"/>
+          </a:xfrm>
+          <a:prstGeom prst="rect">
+            <a:avLst/>
+          </a:prstGeom>
+          <a:noFill/>
+          <a:ln/>
+        </p:spPr>
+        <p:txBody>
+          <a:bodyPr wrap="square" lIns="0" tIns="0" rIns="0" bIns="0" rtlCol="0" anchor="t"/>
+          <a:lstStyle/>
+          <a:p>
+            <a:pPr indent="0" marL="0">
+              <a:buNone/>
+            </a:pPr>
+            <a:r>
+              <a:rPr lang="en-US" sz="1050" dirty="0">
+                <a:solidFill>
+                  <a:schemeClr val="tx2"/>
+                </a:solidFill>
+                <a:latin typeface="Malgun Gothic" pitchFamily="34" charset="0"/>
+                <a:ea typeface="Malgun Gothic" pitchFamily="34" charset="-122"/>
+                <a:cs typeface="Malgun Gothic" pitchFamily="34" charset="-120"/>
+              </a:rPr>
+              <a:t>충전 직전 화면을 놓치지 않는 비율</a:t>
+            </a:r>
+            <a:endParaRPr lang="en-US" sz="1050" dirty="0"/>
+          </a:p>
+        </p:txBody>
+      </p:sp>
+      <p:sp>
+        <p:nvSpPr>
+          <p:cNvPr id="12" name="kpi 4"/>
+          <p:cNvSpPr/>
+          <p:nvPr/>
+        </p:nvSpPr>
+        <p:spPr>
+          <a:xfrm>
+            <a:off x="2606040" y="2029968"/>
+            <a:ext cx="2011680" cy="896112"/>
+          </a:xfrm>
+          <a:prstGeom prst="roundRect">
+            <a:avLst>
+              <a:gd name="adj" fmla="val 8163"/>
+            </a:avLst>
+          </a:prstGeom>
+          <a:solidFill>
+            <a:srgbClr val="EEF9C6"/>
+          </a:solidFill>
+          <a:ln/>
+        </p:spPr>
+      </p:sp>
+      <p:sp>
+        <p:nvSpPr>
+          <p:cNvPr id="13" name="Text 11"/>
+          <p:cNvSpPr txBox="1"/>
+          <p:nvPr/>
+        </p:nvSpPr>
+        <p:spPr>
+          <a:xfrm>
+            <a:off x="2770632" y="2103120"/>
+            <a:ext cx="1737360" cy="384048"/>
+          </a:xfrm>
+          <a:prstGeom prst="rect">
+            <a:avLst/>
+          </a:prstGeom>
+          <a:noFill/>
+          <a:ln/>
+        </p:spPr>
+        <p:txBody>
+          <a:bodyPr wrap="square" lIns="0" tIns="0" rIns="0" bIns="0" rtlCol="0" anchor="ctr"/>
+          <a:lstStyle/>
+          <a:p>
+            <a:pPr indent="0" marL="0">
+              <a:buNone/>
+            </a:pPr>
+            <a:r>
+              <a:rPr lang="en-US" sz="2000" b="1" dirty="0">
+                <a:solidFill>
+                  <a:schemeClr val="tx1"/>
+                </a:solidFill>
+                <a:latin typeface="Malgun Gothic" pitchFamily="34" charset="0"/>
+                <a:ea typeface="Malgun Gothic" pitchFamily="34" charset="-122"/>
+                <a:cs typeface="Malgun Gothic" pitchFamily="34" charset="-120"/>
+              </a:rPr>
+              <a:t>70%</a:t>
+            </a:r>
+            <a:endParaRPr lang="en-US" sz="2000" dirty="0"/>
+          </a:p>
+        </p:txBody>
+      </p:sp>
+      <p:sp>
+        <p:nvSpPr>
+          <p:cNvPr id="14" name="Text 12"/>
+          <p:cNvSpPr txBox="1"/>
+          <p:nvPr/>
+        </p:nvSpPr>
+        <p:spPr>
+          <a:xfrm>
+            <a:off x="2770632" y="2487168"/>
+            <a:ext cx="1783080" cy="411480"/>
+          </a:xfrm>
+          <a:prstGeom prst="rect">
+            <a:avLst/>
+          </a:prstGeom>
+          <a:noFill/>
+          <a:ln/>
+        </p:spPr>
+        <p:txBody>
+          <a:bodyPr wrap="square" lIns="0" tIns="0" rIns="0" bIns="0" rtlCol="0" anchor="t"/>
+          <a:lstStyle/>
+          <a:p>
+            <a:pPr indent="0" marL="0">
+              <a:buNone/>
+            </a:pPr>
+            <a:r>
+              <a:rPr lang="en-US" sz="1050" dirty="0">
+                <a:solidFill>
+                  <a:schemeClr val="tx2"/>
+                </a:solidFill>
+                <a:latin typeface="Malgun Gothic" pitchFamily="34" charset="0"/>
+                <a:ea typeface="Malgun Gothic" pitchFamily="34" charset="-122"/>
+                <a:cs typeface="Malgun Gothic" pitchFamily="34" charset="-120"/>
+              </a:rPr>
+              <a:t>쿨다운에서 '나가기'를 고르는 비율</a:t>
+            </a:r>
+            <a:endParaRPr lang="en-US" sz="1050" dirty="0"/>
+          </a:p>
+        </p:txBody>
+      </p:sp>
+      <p:sp>
+        <p:nvSpPr>
+          <p:cNvPr id="15" name="kpi 5"/>
+          <p:cNvSpPr/>
+          <p:nvPr/>
+        </p:nvSpPr>
+        <p:spPr>
+          <a:xfrm>
+            <a:off x="457200" y="3054096"/>
+            <a:ext cx="2011680" cy="896112"/>
+          </a:xfrm>
+          <a:prstGeom prst="roundRect">
+            <a:avLst>
+              <a:gd name="adj" fmla="val 8163"/>
+            </a:avLst>
+          </a:prstGeom>
+          <a:solidFill>
+            <a:srgbClr val="F3F4F6"/>
+          </a:solidFill>
+          <a:ln/>
+        </p:spPr>
+      </p:sp>
+      <p:sp>
+        <p:nvSpPr>
+          <p:cNvPr id="16" name="Text 14"/>
+          <p:cNvSpPr txBox="1"/>
+          <p:nvPr/>
+        </p:nvSpPr>
+        <p:spPr>
+          <a:xfrm>
+            <a:off x="621792" y="3127248"/>
+            <a:ext cx="1737360" cy="384048"/>
+          </a:xfrm>
+          <a:prstGeom prst="rect">
+            <a:avLst/>
+          </a:prstGeom>
+          <a:noFill/>
+          <a:ln/>
+        </p:spPr>
+        <p:txBody>
+          <a:bodyPr wrap="square" lIns="0" tIns="0" rIns="0" bIns="0" rtlCol="0" anchor="ctr"/>
+          <a:lstStyle/>
+          <a:p>
+            <a:pPr indent="0" marL="0">
+              <a:buNone/>
+            </a:pPr>
+            <a:r>
+              <a:rPr lang="en-US" sz="2000" b="1" dirty="0">
+                <a:solidFill>
+                  <a:schemeClr val="tx1"/>
+                </a:solidFill>
+                <a:latin typeface="Malgun Gothic" pitchFamily="34" charset="0"/>
+                <a:ea typeface="Malgun Gothic" pitchFamily="34" charset="-122"/>
+                <a:cs typeface="Malgun Gothic" pitchFamily="34" charset="-120"/>
+              </a:rPr>
+              <a:t>1초 · 50MB</a:t>
+            </a:r>
+            <a:endParaRPr lang="en-US" sz="2000" dirty="0"/>
+          </a:p>
+        </p:txBody>
+      </p:sp>
+      <p:sp>
+        <p:nvSpPr>
+          <p:cNvPr id="17" name="Text 15"/>
+          <p:cNvSpPr txBox="1"/>
+          <p:nvPr/>
+        </p:nvSpPr>
+        <p:spPr>
+          <a:xfrm>
+            <a:off x="621792" y="3511296"/>
+            <a:ext cx="1783080" cy="411480"/>
+          </a:xfrm>
+          <a:prstGeom prst="rect">
+            <a:avLst/>
+          </a:prstGeom>
+          <a:noFill/>
+          <a:ln/>
+        </p:spPr>
+        <p:txBody>
+          <a:bodyPr wrap="square" lIns="0" tIns="0" rIns="0" bIns="0" rtlCol="0" anchor="t"/>
+          <a:lstStyle/>
+          <a:p>
+            <a:pPr indent="0" marL="0">
+              <a:buNone/>
+            </a:pPr>
+            <a:r>
+              <a:rPr lang="en-US" sz="1050" dirty="0">
+                <a:solidFill>
+                  <a:schemeClr val="tx2"/>
+                </a:solidFill>
+                <a:latin typeface="Malgun Gothic" pitchFamily="34" charset="0"/>
+                <a:ea typeface="Malgun Gothic" pitchFamily="34" charset="-122"/>
+                <a:cs typeface="Malgun Gothic" pitchFamily="34" charset="-120"/>
+              </a:rPr>
+              <a:t>폰 안에서 판정하는 속도 · 크기</a:t>
+            </a:r>
+            <a:endParaRPr lang="en-US" sz="1050" dirty="0"/>
+          </a:p>
+        </p:txBody>
+      </p:sp>
+      <p:sp>
+        <p:nvSpPr>
+          <p:cNvPr id="18" name="kpi 6"/>
+          <p:cNvSpPr/>
+          <p:nvPr/>
+        </p:nvSpPr>
+        <p:spPr>
+          <a:xfrm>
+            <a:off x="2606040" y="3054096"/>
+            <a:ext cx="2011680" cy="896112"/>
+          </a:xfrm>
+          <a:prstGeom prst="roundRect">
+            <a:avLst>
+              <a:gd name="adj" fmla="val 8163"/>
+            </a:avLst>
+          </a:prstGeom>
+          <a:solidFill>
+            <a:srgbClr val="F3F4F6"/>
+          </a:solidFill>
+          <a:ln/>
+        </p:spPr>
+      </p:sp>
+      <p:sp>
+        <p:nvSpPr>
+          <p:cNvPr id="19" name="Text 17"/>
+          <p:cNvSpPr txBox="1"/>
+          <p:nvPr/>
+        </p:nvSpPr>
+        <p:spPr>
+          <a:xfrm>
+            <a:off x="2770632" y="3127248"/>
+            <a:ext cx="1737360" cy="384048"/>
+          </a:xfrm>
+          <a:prstGeom prst="rect">
+            <a:avLst/>
+          </a:prstGeom>
+          <a:noFill/>
+          <a:ln/>
+        </p:spPr>
+        <p:txBody>
+          <a:bodyPr wrap="square" lIns="0" tIns="0" rIns="0" bIns="0" rtlCol="0" anchor="ctr"/>
+          <a:lstStyle/>
+          <a:p>
+            <a:pPr indent="0" marL="0">
+              <a:buNone/>
+            </a:pPr>
+            <a:r>
+              <a:rPr lang="en-US" sz="2000" b="1" dirty="0">
+                <a:solidFill>
+                  <a:schemeClr val="tx1"/>
+                </a:solidFill>
+                <a:latin typeface="Malgun Gothic" pitchFamily="34" charset="0"/>
+                <a:ea typeface="Malgun Gothic" pitchFamily="34" charset="-122"/>
+                <a:cs typeface="Malgun Gothic" pitchFamily="34" charset="-120"/>
+              </a:rPr>
+              <a:t>κ 0.8</a:t>
+            </a:r>
+            <a:endParaRPr lang="en-US" sz="2000" dirty="0"/>
+          </a:p>
+        </p:txBody>
+      </p:sp>
+      <p:sp>
+        <p:nvSpPr>
+          <p:cNvPr id="20" name="Text 18"/>
+          <p:cNvSpPr txBox="1"/>
+          <p:nvPr/>
+        </p:nvSpPr>
+        <p:spPr>
+          <a:xfrm>
+            <a:off x="2770632" y="3511296"/>
+            <a:ext cx="1783080" cy="411480"/>
+          </a:xfrm>
+          <a:prstGeom prst="rect">
+            <a:avLst/>
+          </a:prstGeom>
+          <a:noFill/>
+          <a:ln/>
+        </p:spPr>
+        <p:txBody>
+          <a:bodyPr wrap="square" lIns="0" tIns="0" rIns="0" bIns="0" rtlCol="0" anchor="t"/>
+          <a:lstStyle/>
+          <a:p>
+            <a:pPr indent="0" marL="0">
+              <a:buNone/>
+            </a:pPr>
+            <a:r>
+              <a:rPr lang="en-US" sz="1050" dirty="0">
+                <a:solidFill>
+                  <a:schemeClr val="tx2"/>
+                </a:solidFill>
+                <a:latin typeface="Malgun Gothic" pitchFamily="34" charset="0"/>
+                <a:ea typeface="Malgun Gothic" pitchFamily="34" charset="-122"/>
+                <a:cs typeface="Malgun Gothic" pitchFamily="34" charset="-120"/>
+              </a:rPr>
+              <a:t>라벨을 붙인 두 사람의 일치도</a:t>
+            </a:r>
+            <a:endParaRPr lang="en-US" sz="1050" dirty="0"/>
+          </a:p>
+        </p:txBody>
+      </p:sp>
+      <p:sp>
+        <p:nvSpPr>
+          <p:cNvPr id="21" name="Text 19"/>
+          <p:cNvSpPr txBox="1"/>
+          <p:nvPr/>
+        </p:nvSpPr>
+        <p:spPr>
+          <a:xfrm>
+            <a:off x="457200" y="4114800"/>
+            <a:ext cx="4389120" cy="411480"/>
+          </a:xfrm>
+          <a:prstGeom prst="rect">
+            <a:avLst/>
+          </a:prstGeom>
+          <a:noFill/>
+          <a:ln/>
+        </p:spPr>
+        <p:txBody>
+          <a:bodyPr wrap="square" lIns="0" tIns="0" rIns="0" bIns="0" rtlCol="0" anchor="t"/>
+          <a:lstStyle/>
+          <a:p>
+            <a:pPr indent="0" marL="0">
+              <a:buNone/>
+            </a:pPr>
+            <a:r>
+              <a:rPr lang="en-US" sz="1000" dirty="0">
+                <a:solidFill>
+                  <a:schemeClr val="accent2"/>
+                </a:solidFill>
+                <a:latin typeface="Malgun Gothic" pitchFamily="34" charset="0"/>
+                <a:ea typeface="Malgun Gothic" pitchFamily="34" charset="-122"/>
+                <a:cs typeface="Malgun Gothic" pitchFamily="34" charset="-120"/>
+              </a:rPr>
+              <a:t>수집 현황(10/7): 도박 76 · 정상 70 · 일반 27장 → 7주차 1,000장</a:t>
+            </a:r>
+            <a:endParaRPr lang="en-US" sz="1000" dirty="0"/>
+          </a:p>
+        </p:txBody>
+      </p:sp>
+      <p:sp>
+        <p:nvSpPr>
+          <p:cNvPr id="22" name="Shape 20"/>
+          <p:cNvSpPr/>
+          <p:nvPr/>
+        </p:nvSpPr>
+        <p:spPr>
+          <a:xfrm>
+            <a:off x="5230368" y="1143000"/>
+            <a:ext cx="0" cy="3154680"/>
+          </a:xfrm>
+          <a:prstGeom prst="line">
+            <a:avLst/>
+          </a:prstGeom>
+          <a:noFill/>
+          <a:ln w="25400">
+            <a:solidFill>
+              <a:srgbClr val="E3E5E8"/>
+            </a:solidFill>
+            <a:prstDash val="solid"/>
+          </a:ln>
+        </p:spPr>
+      </p:sp>
+      <p:sp>
+        <p:nvSpPr>
+          <p:cNvPr id="23" name="Shape 21"/>
+          <p:cNvSpPr/>
+          <p:nvPr/>
+        </p:nvSpPr>
+        <p:spPr>
+          <a:xfrm>
+            <a:off x="5120640" y="1078992"/>
+            <a:ext cx="219456" cy="219456"/>
+          </a:xfrm>
+          <a:prstGeom prst="ellipse">
+            <a:avLst/>
+          </a:prstGeom>
+          <a:solidFill>
+            <a:schemeClr val="bg1"/>
+          </a:solidFill>
+          <a:ln w="19050">
+            <a:solidFill>
+              <a:srgbClr val="3A3A40"/>
+            </a:solidFill>
+            <a:prstDash val="solid"/>
+          </a:ln>
+        </p:spPr>
+      </p:sp>
+      <p:sp>
+        <p:nvSpPr>
+          <p:cNvPr id="24" name="Text 22"/>
+          <p:cNvSpPr txBox="1"/>
+          <p:nvPr/>
+        </p:nvSpPr>
+        <p:spPr>
+          <a:xfrm>
+            <a:off x="5486400" y="1005840"/>
+            <a:ext cx="594360" cy="365760"/>
+          </a:xfrm>
+          <a:prstGeom prst="rect">
+            <a:avLst/>
+          </a:prstGeom>
+          <a:noFill/>
+          <a:ln/>
+        </p:spPr>
+        <p:txBody>
+          <a:bodyPr wrap="square" lIns="0" tIns="0" rIns="0" bIns="0" rtlCol="0" anchor="ctr"/>
+          <a:lstStyle/>
+          <a:p>
+            <a:pPr indent="0" marL="0">
+              <a:buNone/>
+            </a:pPr>
+            <a:r>
+              <a:rPr lang="en-US" sz="1300" b="1" dirty="0">
+                <a:solidFill>
+                  <a:schemeClr val="tx1"/>
+                </a:solidFill>
+                <a:latin typeface="Malgun Gothic" pitchFamily="34" charset="0"/>
+                <a:ea typeface="Malgun Gothic" pitchFamily="34" charset="-122"/>
+                <a:cs typeface="Malgun Gothic" pitchFamily="34" charset="-120"/>
+              </a:rPr>
+              <a:t>7주</a:t>
+            </a:r>
+            <a:endParaRPr lang="en-US" sz="1300" dirty="0"/>
+          </a:p>
+        </p:txBody>
+      </p:sp>
+      <p:sp>
+        <p:nvSpPr>
+          <p:cNvPr id="25" name="Text 23"/>
+          <p:cNvSpPr txBox="1"/>
+          <p:nvPr/>
+        </p:nvSpPr>
+        <p:spPr>
+          <a:xfrm>
+            <a:off x="6080760" y="1005840"/>
+            <a:ext cx="2606040" cy="365760"/>
+          </a:xfrm>
+          <a:prstGeom prst="rect">
+            <a:avLst/>
+          </a:prstGeom>
+          <a:noFill/>
+          <a:ln/>
+        </p:spPr>
+        <p:txBody>
+          <a:bodyPr wrap="square" lIns="0" tIns="0" rIns="0" bIns="0" rtlCol="0" anchor="ctr"/>
+          <a:lstStyle/>
+          <a:p>
+            <a:pPr indent="0" marL="0">
+              <a:buNone/>
+            </a:pPr>
+            <a:r>
+              <a:rPr lang="en-US" sz="1200" dirty="0">
+                <a:solidFill>
+                  <a:schemeClr val="tx2"/>
+                </a:solidFill>
+                <a:latin typeface="Malgun Gothic" pitchFamily="34" charset="0"/>
+                <a:ea typeface="Malgun Gothic" pitchFamily="34" charset="-122"/>
+                <a:cs typeface="Malgun Gothic" pitchFamily="34" charset="-120"/>
+              </a:rPr>
+              <a:t>상담사·회복자 인터뷰 · 라벨링 기준서</a:t>
+            </a:r>
+            <a:endParaRPr lang="en-US" sz="1200" dirty="0"/>
+          </a:p>
+        </p:txBody>
+      </p:sp>
+      <p:sp>
+        <p:nvSpPr>
+          <p:cNvPr id="26" name="Shape 24"/>
+          <p:cNvSpPr/>
+          <p:nvPr/>
+        </p:nvSpPr>
+        <p:spPr>
+          <a:xfrm>
+            <a:off x="5120640" y="1764792"/>
+            <a:ext cx="219456" cy="219456"/>
+          </a:xfrm>
+          <a:prstGeom prst="ellipse">
+            <a:avLst/>
+          </a:prstGeom>
+          <a:solidFill>
+            <a:schemeClr val="bg1"/>
+          </a:solidFill>
+          <a:ln w="19050">
+            <a:solidFill>
+              <a:srgbClr val="3A3A40"/>
+            </a:solidFill>
+            <a:prstDash val="solid"/>
+          </a:ln>
+        </p:spPr>
+      </p:sp>
+      <p:sp>
+        <p:nvSpPr>
+          <p:cNvPr id="27" name="Text 25"/>
+          <p:cNvSpPr txBox="1"/>
+          <p:nvPr/>
+        </p:nvSpPr>
+        <p:spPr>
+          <a:xfrm>
+            <a:off x="5486400" y="1691640"/>
+            <a:ext cx="594360" cy="365760"/>
+          </a:xfrm>
+          <a:prstGeom prst="rect">
+            <a:avLst/>
+          </a:prstGeom>
+          <a:noFill/>
+          <a:ln/>
+        </p:spPr>
+        <p:txBody>
+          <a:bodyPr wrap="square" lIns="0" tIns="0" rIns="0" bIns="0" rtlCol="0" anchor="ctr"/>
+          <a:lstStyle/>
+          <a:p>
+            <a:pPr indent="0" marL="0">
+              <a:buNone/>
+            </a:pPr>
+            <a:r>
+              <a:rPr lang="en-US" sz="1300" b="1" dirty="0">
+                <a:solidFill>
+                  <a:schemeClr val="tx1"/>
+                </a:solidFill>
+                <a:latin typeface="Malgun Gothic" pitchFamily="34" charset="0"/>
+                <a:ea typeface="Malgun Gothic" pitchFamily="34" charset="-122"/>
+                <a:cs typeface="Malgun Gothic" pitchFamily="34" charset="-120"/>
+              </a:rPr>
+              <a:t>8주</a:t>
+            </a:r>
+            <a:endParaRPr lang="en-US" sz="1300" dirty="0"/>
+          </a:p>
+        </p:txBody>
+      </p:sp>
+      <p:sp>
+        <p:nvSpPr>
+          <p:cNvPr id="28" name="Text 26"/>
+          <p:cNvSpPr txBox="1"/>
+          <p:nvPr/>
+        </p:nvSpPr>
+        <p:spPr>
+          <a:xfrm>
+            <a:off x="6080760" y="1691640"/>
+            <a:ext cx="2606040" cy="365760"/>
+          </a:xfrm>
+          <a:prstGeom prst="rect">
+            <a:avLst/>
+          </a:prstGeom>
+          <a:noFill/>
+          <a:ln/>
+        </p:spPr>
+        <p:txBody>
+          <a:bodyPr wrap="square" lIns="0" tIns="0" rIns="0" bIns="0" rtlCol="0" anchor="ctr"/>
+          <a:lstStyle/>
+          <a:p>
+            <a:pPr indent="0" marL="0">
+              <a:buNone/>
+            </a:pPr>
+            <a:r>
+              <a:rPr lang="en-US" sz="1200" dirty="0">
+                <a:solidFill>
+                  <a:schemeClr val="tx2"/>
+                </a:solidFill>
+                <a:latin typeface="Malgun Gothic" pitchFamily="34" charset="0"/>
+                <a:ea typeface="Malgun Gothic" pitchFamily="34" charset="-122"/>
+                <a:cs typeface="Malgun Gothic" pitchFamily="34" charset="-120"/>
+              </a:rPr>
+              <a:t>종이 프로토타입 · 15/30/60초 비교</a:t>
+            </a:r>
+            <a:endParaRPr lang="en-US" sz="1200" dirty="0"/>
+          </a:p>
+        </p:txBody>
+      </p:sp>
+      <p:sp>
+        <p:nvSpPr>
+          <p:cNvPr id="29" name="Shape 27"/>
+          <p:cNvSpPr/>
+          <p:nvPr/>
+        </p:nvSpPr>
+        <p:spPr>
+          <a:xfrm>
+            <a:off x="5120640" y="2450592"/>
+            <a:ext cx="219456" cy="219456"/>
+          </a:xfrm>
+          <a:prstGeom prst="ellipse">
+            <a:avLst/>
+          </a:prstGeom>
+          <a:solidFill>
+            <a:schemeClr val="accent1"/>
+          </a:solidFill>
+          <a:ln w="19050">
+            <a:solidFill>
+              <a:srgbClr val="3A3A40"/>
+            </a:solidFill>
+            <a:prstDash val="solid"/>
+          </a:ln>
+        </p:spPr>
+      </p:sp>
+      <p:sp>
+        <p:nvSpPr>
+          <p:cNvPr id="30" name="Text 28"/>
+          <p:cNvSpPr txBox="1"/>
+          <p:nvPr/>
+        </p:nvSpPr>
+        <p:spPr>
+          <a:xfrm>
+            <a:off x="5486400" y="2377440"/>
+            <a:ext cx="594360" cy="365760"/>
+          </a:xfrm>
+          <a:prstGeom prst="rect">
+            <a:avLst/>
+          </a:prstGeom>
+          <a:noFill/>
+          <a:ln/>
+        </p:spPr>
+        <p:txBody>
+          <a:bodyPr wrap="square" lIns="0" tIns="0" rIns="0" bIns="0" rtlCol="0" anchor="ctr"/>
+          <a:lstStyle/>
+          <a:p>
+            <a:pPr indent="0" marL="0">
+              <a:buNone/>
+            </a:pPr>
+            <a:r>
+              <a:rPr lang="en-US" sz="1300" b="1" dirty="0">
+                <a:solidFill>
+                  <a:schemeClr val="tx1"/>
+                </a:solidFill>
+                <a:latin typeface="Malgun Gothic" pitchFamily="34" charset="0"/>
+                <a:ea typeface="Malgun Gothic" pitchFamily="34" charset="-122"/>
+                <a:cs typeface="Malgun Gothic" pitchFamily="34" charset="-120"/>
+              </a:rPr>
+              <a:t>11주</a:t>
+            </a:r>
+            <a:endParaRPr lang="en-US" sz="1300" dirty="0"/>
+          </a:p>
+        </p:txBody>
+      </p:sp>
+      <p:sp>
+        <p:nvSpPr>
+          <p:cNvPr id="31" name="Text 29"/>
+          <p:cNvSpPr txBox="1"/>
+          <p:nvPr/>
+        </p:nvSpPr>
+        <p:spPr>
+          <a:xfrm>
+            <a:off x="6080760" y="2377440"/>
+            <a:ext cx="2606040" cy="365760"/>
+          </a:xfrm>
+          <a:prstGeom prst="rect">
+            <a:avLst/>
+          </a:prstGeom>
+          <a:noFill/>
+          <a:ln/>
+        </p:spPr>
+        <p:txBody>
+          <a:bodyPr wrap="square" lIns="0" tIns="0" rIns="0" bIns="0" rtlCol="0" anchor="ctr"/>
+          <a:lstStyle/>
+          <a:p>
+            <a:pPr indent="0" marL="0">
+              <a:buNone/>
+            </a:pPr>
+            <a:r>
+              <a:rPr lang="en-US" sz="1200" dirty="0">
+                <a:solidFill>
+                  <a:schemeClr val="tx2"/>
+                </a:solidFill>
+                <a:latin typeface="Malgun Gothic" pitchFamily="34" charset="0"/>
+                <a:ea typeface="Malgun Gothic" pitchFamily="34" charset="-122"/>
+                <a:cs typeface="Malgun Gothic" pitchFamily="34" charset="-120"/>
+              </a:rPr>
+              <a:t>중간발표 · 안드로이드 데모 시연</a:t>
+            </a:r>
+            <a:endParaRPr lang="en-US" sz="1200" dirty="0"/>
+          </a:p>
+        </p:txBody>
+      </p:sp>
+      <p:sp>
+        <p:nvSpPr>
+          <p:cNvPr id="32" name="Shape 30"/>
+          <p:cNvSpPr/>
+          <p:nvPr/>
+        </p:nvSpPr>
+        <p:spPr>
+          <a:xfrm>
+            <a:off x="5120640" y="3136392"/>
+            <a:ext cx="219456" cy="219456"/>
+          </a:xfrm>
+          <a:prstGeom prst="ellipse">
+            <a:avLst/>
+          </a:prstGeom>
+          <a:solidFill>
+            <a:schemeClr val="bg1"/>
+          </a:solidFill>
+          <a:ln w="19050">
+            <a:solidFill>
+              <a:srgbClr val="3A3A40"/>
+            </a:solidFill>
+            <a:prstDash val="solid"/>
+          </a:ln>
+        </p:spPr>
+      </p:sp>
+      <p:sp>
+        <p:nvSpPr>
+          <p:cNvPr id="33" name="Text 31"/>
+          <p:cNvSpPr txBox="1"/>
+          <p:nvPr/>
+        </p:nvSpPr>
+        <p:spPr>
+          <a:xfrm>
+            <a:off x="5486400" y="3063240"/>
+            <a:ext cx="594360" cy="365760"/>
+          </a:xfrm>
+          <a:prstGeom prst="rect">
+            <a:avLst/>
+          </a:prstGeom>
+          <a:noFill/>
+          <a:ln/>
+        </p:spPr>
+        <p:txBody>
+          <a:bodyPr wrap="square" lIns="0" tIns="0" rIns="0" bIns="0" rtlCol="0" anchor="ctr"/>
+          <a:lstStyle/>
+          <a:p>
+            <a:pPr indent="0" marL="0">
+              <a:buNone/>
+            </a:pPr>
+            <a:r>
+              <a:rPr lang="en-US" sz="1300" b="1" dirty="0">
+                <a:solidFill>
+                  <a:schemeClr val="tx1"/>
+                </a:solidFill>
+                <a:latin typeface="Malgun Gothic" pitchFamily="34" charset="0"/>
+                <a:ea typeface="Malgun Gothic" pitchFamily="34" charset="-122"/>
+                <a:cs typeface="Malgun Gothic" pitchFamily="34" charset="-120"/>
+              </a:rPr>
+              <a:t>13주</a:t>
+            </a:r>
+            <a:endParaRPr lang="en-US" sz="1300" dirty="0"/>
+          </a:p>
+        </p:txBody>
+      </p:sp>
+      <p:sp>
+        <p:nvSpPr>
+          <p:cNvPr id="34" name="Text 32"/>
+          <p:cNvSpPr txBox="1"/>
+          <p:nvPr/>
+        </p:nvSpPr>
+        <p:spPr>
+          <a:xfrm>
+            <a:off x="6080760" y="3063240"/>
+            <a:ext cx="2606040" cy="365760"/>
+          </a:xfrm>
+          <a:prstGeom prst="rect">
+            <a:avLst/>
+          </a:prstGeom>
+          <a:noFill/>
+          <a:ln/>
+        </p:spPr>
+        <p:txBody>
+          <a:bodyPr wrap="square" lIns="0" tIns="0" rIns="0" bIns="0" rtlCol="0" anchor="ctr"/>
+          <a:lstStyle/>
+          <a:p>
+            <a:pPr indent="0" marL="0">
+              <a:buNone/>
+            </a:pPr>
+            <a:r>
+              <a:rPr lang="en-US" sz="1200" dirty="0">
+                <a:solidFill>
+                  <a:schemeClr val="tx2"/>
+                </a:solidFill>
+                <a:latin typeface="Malgun Gothic" pitchFamily="34" charset="0"/>
+                <a:ea typeface="Malgun Gothic" pitchFamily="34" charset="-122"/>
+                <a:cs typeface="Malgun Gothic" pitchFamily="34" charset="-120"/>
+              </a:rPr>
+              <a:t>2차 테스트 · 장부·신뢰인·1336</a:t>
+            </a:r>
+            <a:endParaRPr lang="en-US" sz="1200" dirty="0"/>
+          </a:p>
+        </p:txBody>
+      </p:sp>
+      <p:sp>
+        <p:nvSpPr>
+          <p:cNvPr id="35" name="Shape 33"/>
+          <p:cNvSpPr/>
+          <p:nvPr/>
+        </p:nvSpPr>
+        <p:spPr>
+          <a:xfrm>
+            <a:off x="5120640" y="3822192"/>
+            <a:ext cx="219456" cy="219456"/>
+          </a:xfrm>
+          <a:prstGeom prst="ellipse">
+            <a:avLst/>
+          </a:prstGeom>
+          <a:solidFill>
+            <a:schemeClr val="bg1"/>
+          </a:solidFill>
+          <a:ln w="19050">
+            <a:solidFill>
+              <a:srgbClr val="3A3A40"/>
+            </a:solidFill>
+            <a:prstDash val="solid"/>
+          </a:ln>
+        </p:spPr>
+      </p:sp>
+      <p:sp>
+        <p:nvSpPr>
+          <p:cNvPr id="36" name="Text 34"/>
+          <p:cNvSpPr txBox="1"/>
+          <p:nvPr/>
+        </p:nvSpPr>
+        <p:spPr>
+          <a:xfrm>
+            <a:off x="5486400" y="3749040"/>
+            <a:ext cx="594360" cy="365760"/>
+          </a:xfrm>
+          <a:prstGeom prst="rect">
+            <a:avLst/>
+          </a:prstGeom>
+          <a:noFill/>
+          <a:ln/>
+        </p:spPr>
+        <p:txBody>
+          <a:bodyPr wrap="square" lIns="0" tIns="0" rIns="0" bIns="0" rtlCol="0" anchor="ctr"/>
+          <a:lstStyle/>
+          <a:p>
+            <a:pPr indent="0" marL="0">
+              <a:buNone/>
+            </a:pPr>
+            <a:r>
+              <a:rPr lang="en-US" sz="1300" b="1" dirty="0">
+                <a:solidFill>
+                  <a:schemeClr val="tx1"/>
+                </a:solidFill>
+                <a:latin typeface="Malgun Gothic" pitchFamily="34" charset="0"/>
+                <a:ea typeface="Malgun Gothic" pitchFamily="34" charset="-122"/>
+                <a:cs typeface="Malgun Gothic" pitchFamily="34" charset="-120"/>
+              </a:rPr>
+              <a:t>15주</a:t>
+            </a:r>
+            <a:endParaRPr lang="en-US" sz="1300" dirty="0"/>
+          </a:p>
+        </p:txBody>
+      </p:sp>
+      <p:sp>
+        <p:nvSpPr>
+          <p:cNvPr id="37" name="Text 35"/>
+          <p:cNvSpPr txBox="1"/>
+          <p:nvPr/>
+        </p:nvSpPr>
+        <p:spPr>
+          <a:xfrm>
+            <a:off x="6080760" y="3749040"/>
+            <a:ext cx="2606040" cy="365760"/>
+          </a:xfrm>
+          <a:prstGeom prst="rect">
+            <a:avLst/>
+          </a:prstGeom>
+          <a:noFill/>
+          <a:ln/>
+        </p:spPr>
+        <p:txBody>
+          <a:bodyPr wrap="square" lIns="0" tIns="0" rIns="0" bIns="0" rtlCol="0" anchor="ctr"/>
+          <a:lstStyle/>
+          <a:p>
+            <a:pPr indent="0" marL="0">
+              <a:buNone/>
+            </a:pPr>
+            <a:r>
+              <a:rPr lang="en-US" sz="1200" dirty="0">
+                <a:solidFill>
+                  <a:schemeClr val="tx2"/>
+                </a:solidFill>
+                <a:latin typeface="Malgun Gothic" pitchFamily="34" charset="0"/>
+                <a:ea typeface="Malgun Gothic" pitchFamily="34" charset="-122"/>
+                <a:cs typeface="Malgun Gothic" pitchFamily="34" charset="-120"/>
+              </a:rPr>
+              <a:t>최종 · 모델 비교 결과 · 데모 영상</a:t>
+            </a:r>
+            <a:endParaRPr lang="en-US" sz="1200" dirty="0"/>
+          </a:p>
+        </p:txBody>
+      </p:sp>
+      <p:sp>
+        <p:nvSpPr>
+          <p:cNvPr id="25" name="Slide Number Placeholder 0"/>
+          <p:cNvSpPr>
+            <a:spLocks noGrp="1"/>
+          </p:cNvSpPr>
+          <p:nvPr>
+            <p:ph type="sldNum" sz="quarter" idx="4294967295"/>
+          </p:nvPr>
+        </p:nvSpPr>
+        <p:spPr>
+          <a:xfrm>
+            <a:off x="8321040" y="4773168"/>
+            <a:ext cx="365760" cy="274320"/>
+          </a:xfrm>
+          <a:prstGeom prst="rect">
+            <a:avLst/>
+          </a:prstGeom>
+          <a:extLst>
+            <a:ext uri="{C572A759-6A51-4108-AA02-DFA0A04FC94B}">
+              <ma14:wrappingTextBoxFlag xmlns:ma14="http://schemas.microsoft.com/office/mac/drawingml/2011/main" val="0"/>
+            </a:ext>
+          </a:extLst>
+        </p:spPr>
+        <p:txBody>
+          <a:bodyPr/>
+          <a:lstStyle>
+            <a:lvl1pPr>
+              <a:defRPr sz="900">
+                <a:solidFill>
+                  <a:schemeClr val="accent2"/>
+                </a:solidFill>
+              </a:defRPr>
+            </a:lvl1pPr>
+          </a:lstStyle>
+          <a:p>
+            <a:pPr algn="r"/>
+            <a:fld id="{F7021451-1387-4CA6-816F-3879F97B5CBC}" type="slidenum">
+              <a:rPr b="0" lang="en-US"/>
+              <a:t>8</a:t>
+            </a:fld>
+            <a:endParaRPr lang="en-US"/>
+          </a:p>
+        </p:txBody>
+      </p:sp>
+    </p:spTree>
+  </p:cSld>
+  <p:clrMapOvr>
+    <a:masterClrMapping/>
+  </p:clrMapOvr>
+</p:sld>
+</file>
+
+<file path=ppt/slides/slide9.xml><?xml version="1.0" encoding="utf-8"?>
+<p:sld xmlns:a="http://schemas.openxmlformats.org/drawingml/2006/main" xmlns:r="http://schemas.openxmlformats.org/officeDocument/2006/relationships" xmlns:p="http://schemas.openxmlformats.org/presentationml/2006/main">
+  <p:cSld name="Slide 9">
+    <p:spTree>
+      <p:nvGrpSpPr>
+        <p:cNvPr id="1" name=""/>
+        <p:cNvGrpSpPr/>
+        <p:nvPr/>
+      </p:nvGrpSpPr>
+      <p:grpSpPr>
+        <a:xfrm>
+          <a:off x="0" y="0"/>
+          <a:ext cx="0" cy="0"/>
+          <a:chOff x="0" y="0"/>
+          <a:chExt cx="0" cy="0"/>
+        </a:xfrm>
+      </p:grpSpPr>
+      <p:sp>
+        <p:nvSpPr>
           <p:cNvPr id="2" name="closing"/>
           <p:cNvSpPr txBox="1"/>
           <p:nvPr/>
@@ -6958,7 +8368,46 @@
       </p:sp>
       <p:sp>
         <p:nvSpPr>
-          <p:cNvPr id="4" name="Text 2"/>
+          <p:cNvPr id="4" name="impact"/>
+          <p:cNvSpPr txBox="1"/>
+          <p:nvPr/>
+        </p:nvSpPr>
+        <p:spPr>
+          <a:xfrm>
+            <a:off x="548640" y="3383280"/>
+            <a:ext cx="5669280" cy="365760"/>
+          </a:xfrm>
+          <a:prstGeom prst="rect">
+            <a:avLst/>
+          </a:prstGeom>
+          <a:noFill/>
+          <a:ln/>
+        </p:spPr>
+        <p:txBody>
+          <a:bodyPr wrap="square" lIns="0" tIns="0" rIns="0" bIns="0" rtlCol="0" anchor="ctr"/>
+          <a:lstStyle/>
+          <a:p>
+            <a:pPr indent="0" marL="0">
+              <a:buNone/>
+            </a:pPr>
+            <a:r>
+              <a:rPr lang="en-US" sz="1400" dirty="0">
+                <a:solidFill>
+                  <a:schemeClr val="accent3"/>
+                </a:solidFill>
+                <a:latin typeface="Malgun Gothic" pitchFamily="34" charset="0"/>
+                <a:ea typeface="Malgun Gothic" pitchFamily="34" charset="-122"/>
+                <a:cs typeface="Malgun Gothic" pitchFamily="34" charset="-120"/>
+              </a:rPr>
+              <a:t>상담 밖에 있는 약 3만 2천 명에게, 상담보다 먼저 닿는다</a:t>
+            </a:r>
+            <a:endParaRPr lang="en-US" sz="1400" dirty="0"/>
+          </a:p>
+        </p:txBody>
+      </p:sp>
+      <p:sp>
+        <p:nvSpPr>
+          <p:cNvPr id="5" name="Text 3"/>
           <p:cNvSpPr txBox="1"/>
           <p:nvPr/>
         </p:nvSpPr>
@@ -6997,7 +8446,7 @@
       </p:sp>
       <p:pic>
         <p:nvPicPr>
-          <p:cNvPr id="5" name="cooldown phone" descr="img/phone3.png">    </p:cNvPr>
+          <p:cNvPr id="6" name="cooldown phone" descr="img/phone3.png">    </p:cNvPr>
           <p:cNvPicPr>
             <a:picLocks noChangeAspect="1"/>
           </p:cNvPicPr>

</xml_diff>

<commit_message>
docs(week5): make form 4 materials company-independent
Drop the "existing security app" deployment path. The concept is now a
standalone app (no "gambling" in name/icon/listing), reached through the
"how to quit" search moment and 1336/counselor referral, with the
detection engine split out as an SDK for later embedding. Updated the
form 4 docx (§1.3, NABC, TO-BE 1, §3.5, §4.2, §4.3, 2.2.1 note), the
concept screens image, and the public presentation copy.

Co-Authored-By: Claude Fable 5.1 <noreply@anthropic.com>
</commit_message>
<xml_diff>
--- a/docs/week5/form4_presentation.pptx
+++ b/docs/week5/form4_presentation.pptx
@@ -774,7 +774,7 @@
           <a:p>
             <a:r>
               <a:rPr lang="en-US" dirty="0"/>
-              <a:t>기존 수단을 보면, 해외 자기차단 앱과 국내 자녀안심 앱은 모두 주소 목록에 의존해서 새 주소 한 번에 뚫립니다. 보호자 통제형은 아이에게 감시로 읽혀 지워지고, 자진신고와 1336은 본인이 찾아가야 작동합니다. 그래서 주소와 무관하게, 재접속과 충전 순간에, 본인이 켜는 개입은 비어 있습니다. 저는 이 자리를 주소가 아니라 화면을 읽어 판정하는 방식으로 채우려고 합니다. 방법은 7장에서 말씀드립니다. 그리고 따로 앱을 깔게 하는 게 아니라, 이미 쓰고 있는 보안 앱의 '내 폰 보호' 기능 안에 넣어서 설치 장벽부터 없앱니다.</a:t>
+              <a:t>기존 수단을 보면, 해외 자기차단 앱과 국내 자녀안심 앱은 모두 주소 목록에 의존해서 새 주소 한 번에 뚫립니다. 보호자 통제형은 아이에게 감시로 읽혀 지워지고, 자진신고와 1336은 본인이 찾아가야 작동합니다. 그래서 주소와 무관하게, 재접속과 충전 순간에, 본인이 켜는 개입은 비어 있습니다. 저는 이 자리를 주소가 아니라 화면을 읽어 판정하는 방식으로 채우려고 합니다. 방법은 7장에서 말씀드립니다. 독립 앱으로 만들되 이름과 아이콘에 도박이라는 말을 쓰지 않아 폰에 흔적이 남지 않게 하고, 아이가 '도박 그만하는 법'을 검색하는 순간과 1336·상담사의 권고를 설치 경로로 삼습니다.</a:t>
             </a:r>
             <a:endParaRPr lang="en-US" dirty="0"/>
           </a:p>
@@ -4172,7 +4172,7 @@
                 <a:ea typeface="Malgun Gothic" pitchFamily="34" charset="-122"/>
                 <a:cs typeface="Malgun Gothic" pitchFamily="34" charset="-120"/>
               </a:rPr>
-              <a:t>따로 깔게 하지 않는다 — 이미 쓰는 보안 앱의 '내 폰 보호' 기능 안에 넣어 설치 장벽을 없앤다</a:t>
+              <a:t>독립 앱 「멈칫」 — 이름·아이콘에 '도박'이 없어 폰에 흔적이 안 남고, '도박 그만하는 법' 검색 순간과 1336·상담사 권고로 닿는다</a:t>
             </a:r>
             <a:endParaRPr lang="en-US" sz="1150" dirty="0"/>
           </a:p>

</xml_diff>